<commit_message>
Remove em dashes from docs, pitch, and deck
Global style: no em dashes. Replaced with hyphens across all markdown, the deck
generator, and regenerated live-voiceover.pptx.

Co-authored-by: Copilot <223556219+Copilot@users.noreply.github.com>
Copilot-Session: 0cf03bec-2c35-4048-b747-f7b5b7261116
</commit_message>
<xml_diff>
--- a/docs/pitch/live-voiceover.pptx
+++ b/docs/pitch/live-voiceover.pptx
@@ -3312,7 +3312,7 @@
                 </a:solidFill>
                 <a:latin typeface="Segoe UI Light"/>
               </a:rPr>
-              <a:t>Mac shipped on-device intelligence to developers years ago. Windows has the hardware and the on-device HD voices — but no public API. Here's the proof, and the ask.</a:t>
+              <a:t>Mac shipped on-device intelligence to developers years ago. Windows has the hardware and the on-device HD voices - but no public API. Here's the proof, and the ask.</a:t>
             </a:r>
           </a:p>
         </p:txBody>
@@ -3355,7 +3355,7 @@
                 </a:solidFill>
                 <a:latin typeface="Segoe UI"/>
               </a:rPr>
-              <a:t>A working reference implementation on Windows' on-device Natural (HD) voices —</a:t>
+              <a:t>A working reference implementation on Windows' on-device Natural (HD) voices -</a:t>
             </a:r>
           </a:p>
           <a:p>
@@ -3744,7 +3744,7 @@
                 </a:solidFill>
                 <a:latin typeface="Segoe UI"/>
               </a:rPr>
-              <a:t>Speaker notes become the narration script — per slide.</a:t>
+              <a:t>Speaker notes become the narration script - per slide.</a:t>
             </a:r>
           </a:p>
           <a:p>
@@ -3807,7 +3807,7 @@
                 </a:solidFill>
                 <a:latin typeface="Segoe UI"/>
               </a:rPr>
-              <a:t>Offline, private, free — Azure upsell for avatars &amp; premium.</a:t>
+              <a:t>Offline, private, free - Azure upsell for avatars &amp; premium.</a:t>
             </a:r>
           </a:p>
         </p:txBody>
@@ -4090,7 +4090,7 @@
                 </a:solidFill>
                 <a:latin typeface="Segoe UI Semibold"/>
               </a:rPr>
-              <a:t>Turn every deck into a narrated, multilingual video — built into the tool, on the device. Even this deck could narrate itself.</a:t>
+              <a:t>Turn every deck into a narrated, multilingual video - built into the tool, on the device. Even this deck could narrate itself.</a:t>
             </a:r>
           </a:p>
         </p:txBody>
@@ -5618,7 +5618,7 @@
                 </a:solidFill>
                 <a:latin typeface="Segoe UI Light"/>
               </a:rPr>
-              <a:t>One API surface. Local-first and free by default — and the same code scales to Azure with your creds.</a:t>
+              <a:t>One API surface. Local-first and free by default - and the same code scales to Azure with your creds.</a:t>
             </a:r>
           </a:p>
         </p:txBody>
@@ -5810,7 +5810,7 @@
                 </a:solidFill>
                 <a:latin typeface="Segoe UI Semibold"/>
               </a:rPr>
-              <a:t>It works — but only as a hack</a:t>
+              <a:t>It works - but only as a hack</a:t>
             </a:r>
           </a:p>
         </p:txBody>
@@ -6026,7 +6026,7 @@
                 </a:solidFill>
                 <a:latin typeface="Segoe UI Semibold"/>
               </a:rPr>
-              <a:t>Unsupported and fragile — exactly the friction that stops real products from shipping on the capability. That's what the API removes.</a:t>
+              <a:t>Unsupported and fragile - exactly the friction that stops real products from shipping on the capability. That's what the API removes.</a:t>
             </a:r>
           </a:p>
         </p:txBody>
@@ -6437,7 +6437,7 @@
                 </a:solidFill>
                 <a:latin typeface="Segoe UI Semibold"/>
               </a:rPr>
-              <a:t>DEFAULT — on-device</a:t>
+              <a:t>DEFAULT - on-device</a:t>
             </a:r>
           </a:p>
         </p:txBody>
@@ -6656,7 +6656,7 @@
                 </a:solidFill>
                 <a:latin typeface="Segoe UI Semibold"/>
               </a:rPr>
-              <a:t>UPSELL — same API + your Azure creds</a:t>
+              <a:t>UPSELL - same API + your Azure creds</a:t>
             </a:r>
           </a:p>
         </p:txBody>
@@ -6742,7 +6742,7 @@
                 </a:solidFill>
                 <a:latin typeface="Segoe UI"/>
               </a:rPr>
-              <a:t>Same code path — credentials switch the backend.</a:t>
+              <a:t>Same code path - credentials switch the backend.</a:t>
             </a:r>
           </a:p>
         </p:txBody>
@@ -6873,7 +6873,7 @@
                 </a:solidFill>
                 <a:latin typeface="Segoe UI Semibold"/>
               </a:rPr>
-              <a:t>Local is the free on-ramp; Azure is the upsell. Apple has no cloud to graduate to — Windows + Azure is a funnel only Microsoft can offer.</a:t>
+              <a:t>Local is the free on-ramp; Azure is the upsell. Apple has no cloud to graduate to - Windows + Azure is a funnel only Microsoft can offer.</a:t>
             </a:r>
           </a:p>
         </p:txBody>
@@ -7278,7 +7278,7 @@
                 </a:solidFill>
                 <a:latin typeface="Segoe UI"/>
               </a:rPr>
-              <a:t>Same surface scales to Azure with credentials — local-first, cloud-optional.</a:t>
+              <a:t>Same surface scales to Azure with credentials - local-first, cloud-optional.</a:t>
             </a:r>
           </a:p>
         </p:txBody>
@@ -7365,7 +7365,7 @@
                 </a:solidFill>
                 <a:latin typeface="Segoe UI Semibold"/>
               </a:rPr>
-              <a:t>Then every app — Edge, Teams, Office, media players, accessibility tools — gets instant, private, multilingual, on-device narration for free, with a paved road to Azure.</a:t>
+              <a:t>Then every app - Edge, Teams, Office, media players, accessibility tools - gets instant, private, multilingual, on-device narration for free, with a paved road to Azure.</a:t>
             </a:r>
           </a:p>
         </p:txBody>
@@ -7621,7 +7621,7 @@
                 </a:solidFill>
                 <a:latin typeface="Segoe UI Light"/>
               </a:rPr>
-              <a:t>Local AI models unlock scenarios cloud can't — offline, private, free, instant. The capability already ships on Windows. Access does not.</a:t>
+              <a:t>Local AI models unlock scenarios cloud can't - offline, private, free, instant. The capability already ships on Windows. Access does not.</a:t>
             </a:r>
           </a:p>
         </p:txBody>
@@ -7946,7 +7946,7 @@
                 </a:solidFill>
                 <a:latin typeface="Segoe UI Semibold"/>
               </a:rPr>
-              <a:t>APPLE — today</a:t>
+              <a:t>APPLE - today</a:t>
             </a:r>
           </a:p>
         </p:txBody>
@@ -8011,7 +8011,7 @@
                 </a:solidFill>
                 <a:latin typeface="Segoe UI"/>
               </a:rPr>
-              <a:t>Apple Foundation Models run on the ANE — exposed to third-party apps.</a:t>
+              <a:t>Apple Foundation Models run on the ANE - exposed to third-party apps.</a:t>
             </a:r>
           </a:p>
           <a:p>
@@ -8165,7 +8165,7 @@
                 </a:solidFill>
                 <a:latin typeface="Segoe UI Semibold"/>
               </a:rPr>
-              <a:t>WINDOWS — today</a:t>
+              <a:t>WINDOWS - today</a:t>
             </a:r>
           </a:p>
         </p:txBody>
@@ -8230,7 +8230,7 @@
                 </a:solidFill>
                 <a:latin typeface="Segoe UI"/>
               </a:rPr>
-              <a:t>They run on the CPU — no special NPU — so nearly every modern PC qualifies.</a:t>
+              <a:t>They run on the CPU - no special NPU - so nearly every modern PC qualifies.</a:t>
             </a:r>
           </a:p>
           <a:p>
@@ -8251,7 +8251,7 @@
                 </a:solidFill>
                 <a:latin typeface="Segoe UI"/>
               </a:rPr>
-              <a:t>But no public API — the capability is locked to first-party features.</a:t>
+              <a:t>But no public API - the capability is locked to first-party features.</a:t>
             </a:r>
           </a:p>
         </p:txBody>
@@ -8294,7 +8294,7 @@
                 </a:solidFill>
                 <a:latin typeface="Segoe UI Semibold"/>
               </a:rPr>
-              <a:t>Comparable on-device capability — running on ordinary hardware. The difference is access, and access is what innovation is built on.</a:t>
+              <a:t>Comparable on-device capability - running on ordinary hardware. The difference is access, and access is what innovation is built on.</a:t>
             </a:r>
           </a:p>
         </p:txBody>
@@ -8703,7 +8703,7 @@
                 </a:solidFill>
                 <a:latin typeface="Segoe UI"/>
               </a:rPr>
-              <a:t>One system-wide model, already offline on every machine that added a voice — apps rely on Windows instead of bundling or downloading their own.</a:t>
+              <a:t>One system-wide model, already offline on every machine that added a voice - apps rely on Windows instead of bundling or downloading their own.</a:t>
             </a:r>
           </a:p>
         </p:txBody>
@@ -8810,7 +8810,7 @@
                 </a:solidFill>
                 <a:latin typeface="Segoe UI"/>
               </a:rPr>
-              <a:t>Forced-HD on-device output is near-identical to Microsoft's cloud neural voices — not the old robotic local voices.</a:t>
+              <a:t>Forced-HD on-device output is near-identical to Microsoft's cloud neural voices - not the old robotic local voices.</a:t>
             </a:r>
           </a:p>
         </p:txBody>
@@ -8917,7 +8917,7 @@
                 </a:solidFill>
                 <a:latin typeface="Segoe UI"/>
               </a:rPr>
-              <a:t>Synthesis is far faster than real time on an ordinary CPU — no NPU required — fast enough to generate speech live on virtually any modern PC.</a:t>
+              <a:t>Synthesis is far faster than real time on an ordinary CPU - no NPU required - fast enough to generate speech live on virtually any modern PC.</a:t>
             </a:r>
           </a:p>
         </p:txBody>
@@ -9004,7 +9004,7 @@
                 </a:solidFill>
                 <a:latin typeface="Segoe UI Semibold"/>
               </a:rPr>
-              <a:t>The capability ships on every Windows machine. The public API to enumerate, load, and drive it does not — so no app can build on it.</a:t>
+              <a:t>The capability ships on every Windows machine. The public API to enumerate, load, and drive it does not - so no app can build on it.</a:t>
             </a:r>
           </a:p>
         </p:txBody>
@@ -9389,7 +9389,7 @@
                 </a:solidFill>
                 <a:latin typeface="Segoe UI"/>
               </a:rPr>
-              <a:t>Its natural voices stream from the CLOUD — a network round-trip and server cost on every play — even though a same-class Natural HD voice now runs on the very same device, offline.</a:t>
+              <a:t>Its natural voices stream from the CLOUD - a network round-trip and server cost on every play - even though a same-class Natural HD voice now runs on the very same device, offline.</a:t>
             </a:r>
           </a:p>
         </p:txBody>
@@ -9433,7 +9433,7 @@
                 </a:solidFill>
                 <a:latin typeface="Segoe UI"/>
               </a:rPr>
-              <a:t>Needs a connection — no offline read-aloud at natural quality.</a:t>
+              <a:t>Needs a connection - no offline read-aloud at natural quality.</a:t>
             </a:r>
           </a:p>
           <a:p>
@@ -9881,7 +9881,7 @@
                 </a:solidFill>
                 <a:latin typeface="Segoe UI Light"/>
               </a:rPr>
-              <a:t>Open the API and the same on-device voice powers new products — and fixes ones Microsoft already ships.</a:t>
+              <a:t>Open the API and the same on-device voice powers new products - and fixes ones Microsoft already ships.</a:t>
             </a:r>
           </a:p>
         </p:txBody>
@@ -10137,7 +10137,7 @@
                 </a:solidFill>
                 <a:latin typeface="Segoe UI"/>
               </a:rPr>
-              <a:t>Proof: “Zava Dental” product video — English (Ava) and French (Remy), Natural HD, fully offline. Same pipeline, only the subtitle language differs.</a:t>
+              <a:t>Proof: “Zava Dental” product video - English (Ava) and French (Remy), Natural HD, fully offline. Same pipeline, only the subtitle language differs.</a:t>
             </a:r>
           </a:p>
           <a:p>
@@ -10265,7 +10265,7 @@
                 </a:solidFill>
                 <a:latin typeface="Segoe UI"/>
               </a:rPr>
-              <a:t>No lip-sync, one voice per language, neutral delivery — this complements studio dubbing, it doesn't replace it. Transformative for the vast middle: training, docs, demos, news, corporate comms, education, UGC, accessibility.</a:t>
+              <a:t>No lip-sync, one voice per language, neutral delivery - this complements studio dubbing, it doesn't replace it. Transformative for the vast middle: training, docs, demos, news, corporate comms, education, UGC, accessibility.</a:t>
             </a:r>
           </a:p>
         </p:txBody>
@@ -10715,7 +10715,7 @@
                 </a:solidFill>
                 <a:latin typeface="Segoe UI"/>
               </a:rPr>
-              <a:t>7 languages: ~18 KB of subtitles vs ~7 MB of dub audio — vs ~812 MB of duplicate dubbed videos.</a:t>
+              <a:t>7 languages: ~18 KB of subtitles vs ~7 MB of dub audio - vs ~812 MB of duplicate dubbed videos.</a:t>
             </a:r>
           </a:p>
           <a:p>
@@ -11188,7 +11188,7 @@
                 </a:solidFill>
                 <a:latin typeface="Segoe UI"/>
               </a:rPr>
-              <a:t>Same HD quality with zero cloud cost, offline, private, instant — no round-trip.</a:t>
+              <a:t>Same HD quality with zero cloud cost, offline, private, instant - no round-trip.</a:t>
             </a:r>
           </a:p>
         </p:txBody>
@@ -11341,7 +11341,7 @@
                 </a:solidFill>
                 <a:latin typeface="Segoe UI"/>
               </a:rPr>
-              <a:t>On-device narration, captions read aloud, accessible documents — no per-minute bill.</a:t>
+              <a:t>On-device narration, captions read aloud, accessible documents - no per-minute bill.</a:t>
             </a:r>
           </a:p>
         </p:txBody>
@@ -11647,7 +11647,7 @@
                 </a:solidFill>
                 <a:latin typeface="Segoe UI"/>
               </a:rPr>
-              <a:t>Private, offline screen narration in the user's language — nothing leaves the machine.</a:t>
+              <a:t>Private, offline screen narration in the user's language - nothing leaves the machine.</a:t>
             </a:r>
           </a:p>
         </p:txBody>

</xml_diff>

<commit_message>
docs: reword em-dash punctuation with grammatically correct alternatives
Replace former em dashes (previously swapped for bare hyphens) across the
pitch and repo docs with proper punctuation: commas, colons, semicolons,
parentheses, and split sentences. Rebuild live-voiceover.pptx from the
reworded build_deck.py. No em dashes remain in any markdown, the deck
generator, or the generated slides.

Co-authored-by: Copilot <223556219+Copilot@users.noreply.github.com>
Copilot-Session: 0cf03bec-2c35-4048-b747-f7b5b7261116
</commit_message>
<xml_diff>
--- a/docs/pitch/live-voiceover.pptx
+++ b/docs/pitch/live-voiceover.pptx
@@ -3312,7 +3312,7 @@
                 </a:solidFill>
                 <a:latin typeface="Segoe UI Light"/>
               </a:rPr>
-              <a:t>Mac shipped on-device intelligence to developers years ago. Windows has the hardware and the on-device HD voices - but no public API. Here's the proof, and the ask.</a:t>
+              <a:t>Mac shipped on-device intelligence to developers years ago. Windows has the hardware and the on-device HD voices, but no public API. Here's the proof, and the ask.</a:t>
             </a:r>
           </a:p>
         </p:txBody>
@@ -3355,7 +3355,7 @@
                 </a:solidFill>
                 <a:latin typeface="Segoe UI"/>
               </a:rPr>
-              <a:t>A working reference implementation on Windows' on-device Natural (HD) voices -</a:t>
+              <a:t>A working reference implementation on Windows' on-device Natural (HD) voices,</a:t>
             </a:r>
           </a:p>
           <a:p>
@@ -3744,7 +3744,7 @@
                 </a:solidFill>
                 <a:latin typeface="Segoe UI"/>
               </a:rPr>
-              <a:t>Speaker notes become the narration script - per slide.</a:t>
+              <a:t>Speaker notes become the narration script, one per slide.</a:t>
             </a:r>
           </a:p>
           <a:p>
@@ -3807,7 +3807,7 @@
                 </a:solidFill>
                 <a:latin typeface="Segoe UI"/>
               </a:rPr>
-              <a:t>Offline, private, free - Azure upsell for avatars &amp; premium.</a:t>
+              <a:t>Offline, private, and free, with an Azure upsell for avatars &amp; premium.</a:t>
             </a:r>
           </a:p>
         </p:txBody>
@@ -4090,7 +4090,7 @@
                 </a:solidFill>
                 <a:latin typeface="Segoe UI Semibold"/>
               </a:rPr>
-              <a:t>Turn every deck into a narrated, multilingual video - built into the tool, on the device. Even this deck could narrate itself.</a:t>
+              <a:t>Turn every deck into a narrated, multilingual video, built into the tool and running on the device. Even this deck could narrate itself.</a:t>
             </a:r>
           </a:p>
         </p:txBody>
@@ -5618,7 +5618,7 @@
                 </a:solidFill>
                 <a:latin typeface="Segoe UI Light"/>
               </a:rPr>
-              <a:t>One API surface. Local-first and free by default - and the same code scales to Azure with your creds.</a:t>
+              <a:t>One API surface. Local-first and free by default, and the same code scales to Azure with your creds.</a:t>
             </a:r>
           </a:p>
         </p:txBody>
@@ -5810,7 +5810,7 @@
                 </a:solidFill>
                 <a:latin typeface="Segoe UI Semibold"/>
               </a:rPr>
-              <a:t>It works - but only as a hack</a:t>
+              <a:t>It works, but only as a hack</a:t>
             </a:r>
           </a:p>
         </p:txBody>
@@ -6026,7 +6026,7 @@
                 </a:solidFill>
                 <a:latin typeface="Segoe UI Semibold"/>
               </a:rPr>
-              <a:t>Unsupported and fragile - exactly the friction that stops real products from shipping on the capability. That's what the API removes.</a:t>
+              <a:t>Unsupported and fragile, exactly the friction that stops real products from shipping on the capability. That's what the API removes.</a:t>
             </a:r>
           </a:p>
         </p:txBody>
@@ -6437,7 +6437,7 @@
                 </a:solidFill>
                 <a:latin typeface="Segoe UI Semibold"/>
               </a:rPr>
-              <a:t>DEFAULT - on-device</a:t>
+              <a:t>DEFAULT: on-device</a:t>
             </a:r>
           </a:p>
         </p:txBody>
@@ -6656,7 +6656,7 @@
                 </a:solidFill>
                 <a:latin typeface="Segoe UI Semibold"/>
               </a:rPr>
-              <a:t>UPSELL - same API + your Azure creds</a:t>
+              <a:t>UPSELL: same API + your Azure creds</a:t>
             </a:r>
           </a:p>
         </p:txBody>
@@ -6742,7 +6742,7 @@
                 </a:solidFill>
                 <a:latin typeface="Segoe UI"/>
               </a:rPr>
-              <a:t>Same code path - credentials switch the backend.</a:t>
+              <a:t>Same code path; credentials switch the backend.</a:t>
             </a:r>
           </a:p>
         </p:txBody>
@@ -6873,7 +6873,7 @@
                 </a:solidFill>
                 <a:latin typeface="Segoe UI Semibold"/>
               </a:rPr>
-              <a:t>Local is the free on-ramp; Azure is the upsell. Apple has no cloud to graduate to - Windows + Azure is a funnel only Microsoft can offer.</a:t>
+              <a:t>Local is the free on-ramp; Azure is the upsell. Apple has no cloud to graduate to; Windows + Azure is a funnel only Microsoft can offer.</a:t>
             </a:r>
           </a:p>
         </p:txBody>
@@ -7278,7 +7278,7 @@
                 </a:solidFill>
                 <a:latin typeface="Segoe UI"/>
               </a:rPr>
-              <a:t>Same surface scales to Azure with credentials - local-first, cloud-optional.</a:t>
+              <a:t>Same surface scales to Azure with credentials, so it's local-first and cloud-optional.</a:t>
             </a:r>
           </a:p>
         </p:txBody>
@@ -7365,7 +7365,7 @@
                 </a:solidFill>
                 <a:latin typeface="Segoe UI Semibold"/>
               </a:rPr>
-              <a:t>Then every app - Edge, Teams, Office, media players, accessibility tools - gets instant, private, multilingual, on-device narration for free, with a paved road to Azure.</a:t>
+              <a:t>Then every app (Edge, Teams, Office, media players, accessibility tools) gets instant, private, multilingual, on-device narration for free, with a paved road to Azure.</a:t>
             </a:r>
           </a:p>
         </p:txBody>
@@ -7621,7 +7621,7 @@
                 </a:solidFill>
                 <a:latin typeface="Segoe UI Light"/>
               </a:rPr>
-              <a:t>Local AI models unlock scenarios cloud can't - offline, private, free, instant. The capability already ships on Windows. Access does not.</a:t>
+              <a:t>Local AI models unlock scenarios cloud can't: offline, private, free, instant. The capability already ships on Windows. Access does not.</a:t>
             </a:r>
           </a:p>
         </p:txBody>
@@ -7946,7 +7946,7 @@
                 </a:solidFill>
                 <a:latin typeface="Segoe UI Semibold"/>
               </a:rPr>
-              <a:t>APPLE - today</a:t>
+              <a:t>APPLE · today</a:t>
             </a:r>
           </a:p>
         </p:txBody>
@@ -8011,7 +8011,7 @@
                 </a:solidFill>
                 <a:latin typeface="Segoe UI"/>
               </a:rPr>
-              <a:t>Apple Foundation Models run on the ANE - exposed to third-party apps.</a:t>
+              <a:t>Apple Foundation Models run on the ANE, exposed to third-party apps.</a:t>
             </a:r>
           </a:p>
           <a:p>
@@ -8165,7 +8165,7 @@
                 </a:solidFill>
                 <a:latin typeface="Segoe UI Semibold"/>
               </a:rPr>
-              <a:t>WINDOWS - today</a:t>
+              <a:t>WINDOWS · today</a:t>
             </a:r>
           </a:p>
         </p:txBody>
@@ -8230,7 +8230,7 @@
                 </a:solidFill>
                 <a:latin typeface="Segoe UI"/>
               </a:rPr>
-              <a:t>They run on the CPU - no special NPU - so nearly every modern PC qualifies.</a:t>
+              <a:t>They run on the CPU (no special NPU), so nearly every modern PC qualifies.</a:t>
             </a:r>
           </a:p>
           <a:p>
@@ -8251,7 +8251,7 @@
                 </a:solidFill>
                 <a:latin typeface="Segoe UI"/>
               </a:rPr>
-              <a:t>But no public API - the capability is locked to first-party features.</a:t>
+              <a:t>But no public API exists, so the capability is locked to first-party features.</a:t>
             </a:r>
           </a:p>
         </p:txBody>
@@ -8294,7 +8294,7 @@
                 </a:solidFill>
                 <a:latin typeface="Segoe UI Semibold"/>
               </a:rPr>
-              <a:t>Comparable on-device capability - running on ordinary hardware. The difference is access, and access is what innovation is built on.</a:t>
+              <a:t>Comparable on-device capability, running on ordinary hardware. The difference is access, and access is what innovation is built on.</a:t>
             </a:r>
           </a:p>
         </p:txBody>
@@ -8703,7 +8703,7 @@
                 </a:solidFill>
                 <a:latin typeface="Segoe UI"/>
               </a:rPr>
-              <a:t>One system-wide model, already offline on every machine that added a voice - apps rely on Windows instead of bundling or downloading their own.</a:t>
+              <a:t>One system-wide model, already offline on every machine that added a voice, so apps rely on Windows instead of bundling or downloading their own.</a:t>
             </a:r>
           </a:p>
         </p:txBody>
@@ -8810,7 +8810,7 @@
                 </a:solidFill>
                 <a:latin typeface="Segoe UI"/>
               </a:rPr>
-              <a:t>Forced-HD on-device output is near-identical to Microsoft's cloud neural voices - not the old robotic local voices.</a:t>
+              <a:t>Forced-HD on-device output is near-identical to Microsoft's cloud neural voices, not the old robotic local voices.</a:t>
             </a:r>
           </a:p>
         </p:txBody>
@@ -8917,7 +8917,7 @@
                 </a:solidFill>
                 <a:latin typeface="Segoe UI"/>
               </a:rPr>
-              <a:t>Synthesis is far faster than real time on an ordinary CPU - no NPU required - fast enough to generate speech live on virtually any modern PC.</a:t>
+              <a:t>Synthesis is far faster than real time on an ordinary CPU, needs no NPU, and is fast enough to generate speech live on virtually any modern PC.</a:t>
             </a:r>
           </a:p>
         </p:txBody>
@@ -9004,7 +9004,7 @@
                 </a:solidFill>
                 <a:latin typeface="Segoe UI Semibold"/>
               </a:rPr>
-              <a:t>The capability ships on every Windows machine. The public API to enumerate, load, and drive it does not - so no app can build on it.</a:t>
+              <a:t>The capability ships on every Windows machine. The public API to enumerate, load, and drive it does not, so no app can build on it.</a:t>
             </a:r>
           </a:p>
         </p:txBody>
@@ -9389,7 +9389,7 @@
                 </a:solidFill>
                 <a:latin typeface="Segoe UI"/>
               </a:rPr>
-              <a:t>Its natural voices stream from the CLOUD - a network round-trip and server cost on every play - even though a same-class Natural HD voice now runs on the very same device, offline.</a:t>
+              <a:t>Its natural voices stream from the CLOUD (a network round-trip and server cost on every play), even though a same-class Natural HD voice now runs on the very same device, offline.</a:t>
             </a:r>
           </a:p>
         </p:txBody>
@@ -9433,7 +9433,7 @@
                 </a:solidFill>
                 <a:latin typeface="Segoe UI"/>
               </a:rPr>
-              <a:t>Needs a connection - no offline read-aloud at natural quality.</a:t>
+              <a:t>Needs a connection, with no offline read-aloud at natural quality.</a:t>
             </a:r>
           </a:p>
           <a:p>
@@ -9881,7 +9881,7 @@
                 </a:solidFill>
                 <a:latin typeface="Segoe UI Light"/>
               </a:rPr>
-              <a:t>Open the API and the same on-device voice powers new products - and fixes ones Microsoft already ships.</a:t>
+              <a:t>Open the API and the same on-device voice powers new products, and fixes ones Microsoft already ships.</a:t>
             </a:r>
           </a:p>
         </p:txBody>
@@ -10137,7 +10137,7 @@
                 </a:solidFill>
                 <a:latin typeface="Segoe UI"/>
               </a:rPr>
-              <a:t>Proof: “Zava Dental” product video - English (Ava) and French (Remy), Natural HD, fully offline. Same pipeline, only the subtitle language differs.</a:t>
+              <a:t>Proof: “Zava Dental” product video, voiced in English (Ava) and French (Remy), Natural HD, fully offline. Same pipeline, only the subtitle language differs.</a:t>
             </a:r>
           </a:p>
           <a:p>
@@ -10265,7 +10265,7 @@
                 </a:solidFill>
                 <a:latin typeface="Segoe UI"/>
               </a:rPr>
-              <a:t>No lip-sync, one voice per language, neutral delivery - this complements studio dubbing, it doesn't replace it. Transformative for the vast middle: training, docs, demos, news, corporate comms, education, UGC, accessibility.</a:t>
+              <a:t>No lip-sync, one voice per language, neutral delivery. This complements studio dubbing; it doesn't replace it. It's transformative for the vast middle: training, docs, demos, news, corporate comms, education, UGC, accessibility.</a:t>
             </a:r>
           </a:p>
         </p:txBody>
@@ -10715,7 +10715,7 @@
                 </a:solidFill>
                 <a:latin typeface="Segoe UI"/>
               </a:rPr>
-              <a:t>7 languages: ~18 KB of subtitles vs ~7 MB of dub audio - vs ~812 MB of duplicate dubbed videos.</a:t>
+              <a:t>7 languages: ~18 KB of subtitles vs ~7 MB of dub audio, versus ~812 MB of duplicate dubbed videos.</a:t>
             </a:r>
           </a:p>
           <a:p>
@@ -11188,7 +11188,7 @@
                 </a:solidFill>
                 <a:latin typeface="Segoe UI"/>
               </a:rPr>
-              <a:t>Same HD quality with zero cloud cost, offline, private, instant - no round-trip.</a:t>
+              <a:t>Same HD quality with zero cloud cost, offline, private, and instant, with no round-trip.</a:t>
             </a:r>
           </a:p>
         </p:txBody>
@@ -11341,7 +11341,7 @@
                 </a:solidFill>
                 <a:latin typeface="Segoe UI"/>
               </a:rPr>
-              <a:t>On-device narration, captions read aloud, accessible documents - no per-minute bill.</a:t>
+              <a:t>On-device narration, captions read aloud, and accessible documents, with no per-minute bill.</a:t>
             </a:r>
           </a:p>
         </p:txBody>
@@ -11647,7 +11647,7 @@
                 </a:solidFill>
                 <a:latin typeface="Segoe UI"/>
               </a:rPr>
-              <a:t>Private, offline screen narration in the user's language - nothing leaves the machine.</a:t>
+              <a:t>Private, offline screen narration in the user's language, so nothing leaves the machine.</a:t>
             </a:r>
           </a:p>
         </p:txBody>

</xml_diff>

<commit_message>
docs(pitch): lead with the opportunity, reframe Mac as proof not the lead
Title slide now leads with the local-AI opportunity instead of "Mac shipped
it years ago." The WHY lands on opportunity and reframes the Mac slide as
"Mac proves the model; Windows can take it further": Mac has almost the
equivalent on-device, but only Microsoft pairs it with Azure and its own
product suite (Edge, Office, Teams, PowerPoint, Clipchamp), turning a proven
idea into a platform advantage. MD mirrors the deck. No em dashes.

Co-authored-by: Copilot <223556219+Copilot@users.noreply.github.com>
Copilot-Session: 0cf03bec-2c35-4048-b747-f7b5b7261116
</commit_message>
<xml_diff>
--- a/docs/pitch/live-voiceover.pptx
+++ b/docs/pitch/live-voiceover.pptx
@@ -3312,7 +3312,7 @@
                 </a:solidFill>
                 <a:latin typeface="Segoe UI Light"/>
               </a:rPr>
-              <a:t>Mac shipped on-device intelligence to developers years ago. Windows has the hardware and the on-device HD voices, but no public API. Here's the proof, and the ask.</a:t>
+              <a:t>Local AI unlocks a new class of experiences: offline, private, instant, and free. Windows already ships the on-device HD voices and the hardware to run them. The one thing missing is the public API to build on. Here's the proof, and the ask.</a:t>
             </a:r>
           </a:p>
         </p:txBody>
@@ -7770,7 +7770,7 @@
                 </a:solidFill>
                 <a:latin typeface="Segoe UI Semibold"/>
               </a:rPr>
-              <a:t>WHY · THE GAP</a:t>
+              <a:t>WHY · THE OPPORTUNITY</a:t>
             </a:r>
           </a:p>
         </p:txBody>
@@ -7813,7 +7813,7 @@
                 </a:solidFill>
                 <a:latin typeface="Segoe UI Semibold"/>
               </a:rPr>
-              <a:t>Mac has shipped this to developers for years</a:t>
+              <a:t>Mac proves the model; Windows can take it further</a:t>
             </a:r>
           </a:p>
         </p:txBody>
@@ -7946,7 +7946,7 @@
                 </a:solidFill>
                 <a:latin typeface="Segoe UI Semibold"/>
               </a:rPr>
-              <a:t>APPLE · today</a:t>
+              <a:t>APPLE · proven, but capped</a:t>
             </a:r>
           </a:p>
         </p:txBody>
@@ -7990,7 +7990,7 @@
                 </a:solidFill>
                 <a:latin typeface="Segoe UI"/>
               </a:rPr>
-              <a:t>On-device speech (SpeechAnalyzer) and on-device neural TTS.</a:t>
+              <a:t>On-device speech and neural TTS already ship to third-party apps.</a:t>
             </a:r>
           </a:p>
           <a:p>
@@ -8011,7 +8011,7 @@
                 </a:solidFill>
                 <a:latin typeface="Segoe UI"/>
               </a:rPr>
-              <a:t>Apple Foundation Models run on the ANE, exposed to third-party apps.</a:t>
+              <a:t>It proves local-first AI is real, shipped, and wanted by developers.</a:t>
             </a:r>
           </a:p>
           <a:p>
@@ -8032,7 +8032,7 @@
                 </a:solidFill>
                 <a:latin typeface="Segoe UI"/>
               </a:rPr>
-              <a:t>Local-first AI apps ship on Mac &amp; iPhone right now.</a:t>
+              <a:t>But there is no cloud to graduate to: Apple cannot scale you past the device.</a:t>
             </a:r>
           </a:p>
         </p:txBody>
@@ -8098,7 +8098,7 @@
             <a:avLst/>
           </a:prstGeom>
           <a:solidFill>
-            <a:srgbClr val="606060"/>
+            <a:srgbClr val="0078D4"/>
           </a:solidFill>
           <a:ln>
             <a:noFill/>
@@ -8165,7 +8165,7 @@
                 </a:solidFill>
                 <a:latin typeface="Segoe UI Semibold"/>
               </a:rPr>
-              <a:t>WINDOWS · today</a:t>
+              <a:t>WINDOWS + AZURE · the bigger story</a:t>
             </a:r>
           </a:p>
         </p:txBody>
@@ -8209,7 +8209,7 @@
                 </a:solidFill>
                 <a:latin typeface="Segoe UI"/>
               </a:rPr>
-              <a:t>On-device Natural (HD) voices + local models already on the machine.</a:t>
+              <a:t>The same on-device HD voices are already on the machine, free and offline.</a:t>
             </a:r>
           </a:p>
           <a:p>
@@ -8230,7 +8230,7 @@
                 </a:solidFill>
                 <a:latin typeface="Segoe UI"/>
               </a:rPr>
-              <a:t>They run on the CPU (no special NPU), so nearly every modern PC qualifies.</a:t>
+              <a:t>One API can scale from local to Azure with your credentials, no rewrite.</a:t>
             </a:r>
           </a:p>
           <a:p>
@@ -8251,7 +8251,7 @@
                 </a:solidFill>
                 <a:latin typeface="Segoe UI"/>
               </a:rPr>
-              <a:t>But no public API exists, so the capability is locked to first-party features.</a:t>
+              <a:t>First-party reach (Edge, Office, Teams, PowerPoint, Clipchamp) no rival matches.</a:t>
             </a:r>
           </a:p>
         </p:txBody>
@@ -8294,7 +8294,7 @@
                 </a:solidFill>
                 <a:latin typeface="Segoe UI Semibold"/>
               </a:rPr>
-              <a:t>Comparable on-device capability, running on ordinary hardware. The difference is access, and access is what innovation is built on.</a:t>
+              <a:t>Mac already has almost the equivalent on-device. Only Microsoft can pair it with Azure and its own product suite, turning a proven idea into a platform advantage.</a:t>
             </a:r>
           </a:p>
         </p:txBody>

</xml_diff>

<commit_message>
docs(pitch): weave Phase 3 round-trip conversation loop into the deck
Enrich the WHAT complete-platform slide and the HOW ask slide (and their
live-voiceover.md source) with the shipped SpeechConversation orchestrator:
capture -> endpoint -> recognize -> respond -> speak, with barge-in and the
'understand' step framed as a drop-in on-device AI extensibility point. Add
the ConversationLoop sample and streaming-recognition capabilities to the
repo-contents and ask lists. Regenerated live-voiceover.pptx.

Co-authored-by: Copilot <223556219+Copilot@users.noreply.github.com>
Copilot-Session: 0cf03bec-2c35-4048-b747-f7b5b7261116
</commit_message>
<xml_diff>
--- a/docs/pitch/live-voiceover.pptx
+++ b/docs/pitch/live-voiceover.pptx
@@ -20,6 +20,8 @@
     <p:sldId id="268" r:id="rId19"/>
     <p:sldId id="269" r:id="rId20"/>
     <p:sldId id="270" r:id="rId21"/>
+    <p:sldId id="271" r:id="rId22"/>
+    <p:sldId id="272" r:id="rId23"/>
   </p:sldIdLst>
   <p:sldSz cx="12191695" cy="6858000" type="screen4x3"/>
   <p:notesSz cx="6858000" cy="9144000"/>
@@ -3312,7 +3314,7 @@
                 </a:solidFill>
                 <a:latin typeface="Segoe UI Light"/>
               </a:rPr>
-              <a:t>Local AI unlocks a new class of experiences: offline, private, instant, and free. Windows already ships the on-device HD voices and the hardware to run them. The one thing missing is the public API to build on. Here's the proof, and the ask.</a:t>
+              <a:t>Local AI unlocks a new class of experiences: offline, private, instant, and free. Windows already ships the on-device HD voices, the speech recognition, and the hardware to run both. The one thing missing is the public API to build on. Here's the proof, and the ask.</a:t>
             </a:r>
           </a:p>
         </p:txBody>
@@ -3355,7 +3357,7 @@
                 </a:solidFill>
                 <a:latin typeface="Segoe UI"/>
               </a:rPr>
-              <a:t>A working reference implementation on Windows' on-device Natural (HD) voices,</a:t>
+              <a:t>A working reference implementation on Windows' on-device speech (HD voices + recognition),</a:t>
             </a:r>
           </a:p>
           <a:p>
@@ -4133,7 +4135,7 @@
                 </a:solidFill>
                 <a:latin typeface="Segoe UI"/>
               </a:rPr>
-              <a:t>WindowsNaturalVoices  ·  on-device HD voices, offline</a:t>
+              <a:t>WindowsNaturalVoices  ·  on-device speech, offline</a:t>
             </a:r>
           </a:p>
         </p:txBody>
@@ -5319,7 +5321,7 @@
                 </a:solidFill>
                 <a:latin typeface="Segoe UI"/>
               </a:rPr>
-              <a:t>WindowsNaturalVoices  ·  on-device HD voices, offline</a:t>
+              <a:t>WindowsNaturalVoices  ·  on-device speech, offline</a:t>
             </a:r>
           </a:p>
         </p:txBody>
@@ -5400,7 +5402,7 @@
             <a:avLst/>
           </a:prstGeom>
           <a:solidFill>
-            <a:srgbClr val="103A5E"/>
+            <a:srgbClr val="FFFFFF"/>
           </a:solidFill>
           <a:ln>
             <a:noFill/>
@@ -5438,51 +5440,7 @@
         <p:spPr>
           <a:xfrm>
             <a:off x="0" y="0"/>
-            <a:ext cx="12191695" cy="201168"/>
-          </a:xfrm>
-          <a:prstGeom prst="rect">
-            <a:avLst/>
-          </a:prstGeom>
-          <a:solidFill>
-            <a:srgbClr val="CA5F00"/>
-          </a:solidFill>
-          <a:ln>
-            <a:noFill/>
-          </a:ln>
-          <a:effectLst/>
-        </p:spPr>
-        <p:style>
-          <a:lnRef idx="1">
-            <a:schemeClr val="accent1"/>
-          </a:lnRef>
-          <a:fillRef idx="3">
-            <a:schemeClr val="accent1"/>
-          </a:fillRef>
-          <a:effectRef idx="2">
-            <a:schemeClr val="accent1"/>
-          </a:effectRef>
-          <a:fontRef idx="minor">
-            <a:schemeClr val="lt1"/>
-          </a:fontRef>
-        </p:style>
-        <p:txBody>
-          <a:bodyPr rtlCol="0" anchor="ctr"/>
-          <a:lstStyle/>
-          <a:p>
-            <a:pPr algn="ctr"/>
-          </a:p>
-        </p:txBody>
-      </p:sp>
-      <p:sp>
-        <p:nvSpPr>
-          <p:cNvPr id="4" name="Rectangle 3"/>
-          <p:cNvSpPr/>
-          <p:nvPr/>
-        </p:nvSpPr>
-        <p:spPr>
-          <a:xfrm>
-            <a:off x="777240" y="3566160"/>
-            <a:ext cx="1371600" cy="82296"/>
+            <a:ext cx="12191695" cy="146304"/>
           </a:xfrm>
           <a:prstGeom prst="rect">
             <a:avLst/>
@@ -5519,14 +5477,14 @@
       </p:sp>
       <p:sp>
         <p:nvSpPr>
-          <p:cNvPr id="5" name="TextBox 4"/>
+          <p:cNvPr id="4" name="TextBox 3"/>
           <p:cNvSpPr txBox="1"/>
           <p:nvPr/>
         </p:nvSpPr>
         <p:spPr>
           <a:xfrm>
-            <a:off x="777240" y="2331720"/>
-            <a:ext cx="10607040" cy="640080"/>
+            <a:off x="502920" y="411480"/>
+            <a:ext cx="11155680" cy="365760"/>
           </a:xfrm>
           <a:prstGeom prst="rect">
             <a:avLst/>
@@ -5549,27 +5507,27 @@
               <a:buNone/>
             </a:pPr>
             <a:r>
-              <a:rPr sz="2200" b="1">
+              <a:rPr sz="1300" b="1">
                 <a:solidFill>
                   <a:srgbClr val="00998A"/>
                 </a:solidFill>
                 <a:latin typeface="Segoe UI Semibold"/>
               </a:rPr>
-              <a:t>HOW</a:t>
-            </a:r>
-          </a:p>
-        </p:txBody>
-      </p:sp>
-      <p:sp>
-        <p:nvSpPr>
-          <p:cNvPr id="6" name="TextBox 5"/>
+              <a:t>WHAT · THE COMPLETE PLATFORM</a:t>
+            </a:r>
+          </a:p>
+        </p:txBody>
+      </p:sp>
+      <p:sp>
+        <p:nvSpPr>
+          <p:cNvPr id="5" name="TextBox 4"/>
           <p:cNvSpPr txBox="1"/>
           <p:nvPr/>
         </p:nvSpPr>
         <p:spPr>
           <a:xfrm>
-            <a:off x="777240" y="3886200"/>
-            <a:ext cx="10607040" cy="2011680"/>
+            <a:off x="502920" y="777240"/>
+            <a:ext cx="11155680" cy="914400"/>
           </a:xfrm>
           <a:prstGeom prst="rect">
             <a:avLst/>
@@ -5587,38 +5545,317 @@
                 <a:spcPts val="0"/>
               </a:spcBef>
               <a:spcAft>
-                <a:spcPts val="1000"/>
-              </a:spcAft>
-              <a:buNone/>
-            </a:pPr>
-            <a:r>
-              <a:rPr sz="3800" b="1">
-                <a:solidFill>
-                  <a:srgbClr val="FFFFFF"/>
+                <a:spcPts val="0"/>
+              </a:spcAft>
+              <a:buNone/>
+            </a:pPr>
+            <a:r>
+              <a:rPr sz="3000" b="1">
+                <a:solidFill>
+                  <a:srgbClr val="1F1F1F"/>
                 </a:solidFill>
                 <a:latin typeface="Segoe UI Semibold"/>
               </a:rPr>
-              <a:t>Make the POC real: remove the hack, ship the API</a:t>
-            </a:r>
-          </a:p>
-          <a:p>
-            <a:pPr algn="l">
-              <a:spcBef>
-                <a:spcPts val="0"/>
-              </a:spcBef>
-              <a:spcAft>
-                <a:spcPts val="0"/>
-              </a:spcAft>
-              <a:buNone/>
-            </a:pPr>
-            <a:r>
-              <a:rPr sz="1800" b="0">
-                <a:solidFill>
-                  <a:srgbClr val="CFE0F3"/>
-                </a:solidFill>
-                <a:latin typeface="Segoe UI Light"/>
-              </a:rPr>
-              <a:t>One API surface. Local-first and free by default, and the same code scales to Azure with your creds.</a:t>
+              <a:t>TTS is only half. Windows already listens, too.</a:t>
+            </a:r>
+          </a:p>
+        </p:txBody>
+      </p:sp>
+      <p:sp>
+        <p:nvSpPr>
+          <p:cNvPr id="6" name="TextBox 5"/>
+          <p:cNvSpPr txBox="1"/>
+          <p:nvPr/>
+        </p:nvSpPr>
+        <p:spPr>
+          <a:xfrm>
+            <a:off x="640080" y="1737360"/>
+            <a:ext cx="10881360" cy="2651760"/>
+          </a:xfrm>
+          <a:prstGeom prst="rect">
+            <a:avLst/>
+          </a:prstGeom>
+          <a:noFill/>
+        </p:spPr>
+        <p:txBody>
+          <a:bodyPr wrap="square" lIns="0" rIns="0" tIns="0" bIns="0">
+            <a:spAutoFit/>
+          </a:bodyPr>
+          <a:lstStyle/>
+          <a:p>
+            <a:pPr algn="l">
+              <a:spcBef>
+                <a:spcPts val="0"/>
+              </a:spcBef>
+              <a:spcAft>
+                <a:spcPts val="800"/>
+              </a:spcAft>
+              <a:buNone/>
+            </a:pPr>
+            <a:r>
+              <a:rPr sz="1450" b="1">
+                <a:solidFill>
+                  <a:srgbClr val="103A5E"/>
+                </a:solidFill>
+                <a:latin typeface="Segoe UI Semibold"/>
+              </a:rPr>
+              <a:t>The same story runs on the input side: Windows ships the on-device Live Captions recognizer, offline, on the CPU, with no NPU.</a:t>
+            </a:r>
+          </a:p>
+          <a:p>
+            <a:pPr algn="l">
+              <a:spcBef>
+                <a:spcPts val="0"/>
+              </a:spcBef>
+              <a:spcAft>
+                <a:spcPts val="800"/>
+              </a:spcAft>
+              <a:buFont typeface="Segoe UI"/>
+              <a:buChar char="•"/>
+            </a:pPr>
+            <a:r>
+              <a:rPr sz="1450" b="0">
+                <a:solidFill>
+                  <a:srgbClr val="1F1F1F"/>
+                </a:solidFill>
+                <a:latin typeface="Segoe UI"/>
+              </a:rPr>
+              <a:t>A call listener: one recognizer per speaker, finals-only punctuated sentences, merged into a single two-party transcript, the pattern Contoso-Finance uses on Mac.</a:t>
+            </a:r>
+          </a:p>
+          <a:p>
+            <a:pPr algn="l">
+              <a:spcBef>
+                <a:spcPts val="0"/>
+              </a:spcBef>
+              <a:spcAft>
+                <a:spcPts val="800"/>
+              </a:spcAft>
+              <a:buFont typeface="Segoe UI"/>
+              <a:buChar char="•"/>
+            </a:pPr>
+            <a:r>
+              <a:rPr sz="1450" b="0">
+                <a:solidFill>
+                  <a:srgbClr val="1F1F1F"/>
+                </a:solidFill>
+                <a:latin typeface="Segoe UI"/>
+              </a:rPr>
+              <a:t>And it closes the loop: a conversation orchestrator captures the mic, endpoints each turn, recognizes it, and speaks the reply, with barge-in, and one place to plug in intelligence (an on-device LLM).</a:t>
+            </a:r>
+          </a:p>
+          <a:p>
+            <a:pPr algn="l">
+              <a:spcBef>
+                <a:spcPts val="0"/>
+              </a:spcBef>
+              <a:spcAft>
+                <a:spcPts val="800"/>
+              </a:spcAft>
+              <a:buFont typeface="Segoe UI"/>
+              <a:buChar char="•"/>
+            </a:pPr>
+            <a:r>
+              <a:rPr sz="1450" b="0">
+                <a:solidFill>
+                  <a:srgbClr val="1F1F1F"/>
+                </a:solidFill>
+                <a:latin typeface="Segoe UI"/>
+              </a:rPr>
+              <a:t>Pair it with the HD voices for a complete round-trip platform, speech-in and speech-out, both on-device, both already in Windows, free, private, and offline.</a:t>
+            </a:r>
+          </a:p>
+        </p:txBody>
+      </p:sp>
+      <p:sp>
+        <p:nvSpPr>
+          <p:cNvPr id="7" name="Rectangle 6"/>
+          <p:cNvSpPr/>
+          <p:nvPr/>
+        </p:nvSpPr>
+        <p:spPr>
+          <a:xfrm>
+            <a:off x="640080" y="4663440"/>
+            <a:ext cx="10881360" cy="1371600"/>
+          </a:xfrm>
+          <a:prstGeom prst="rect">
+            <a:avLst/>
+          </a:prstGeom>
+          <a:solidFill>
+            <a:srgbClr val="EAF1FB"/>
+          </a:solidFill>
+          <a:ln>
+            <a:noFill/>
+          </a:ln>
+          <a:effectLst/>
+        </p:spPr>
+        <p:style>
+          <a:lnRef idx="1">
+            <a:schemeClr val="accent1"/>
+          </a:lnRef>
+          <a:fillRef idx="3">
+            <a:schemeClr val="accent1"/>
+          </a:fillRef>
+          <a:effectRef idx="2">
+            <a:schemeClr val="accent1"/>
+          </a:effectRef>
+          <a:fontRef idx="minor">
+            <a:schemeClr val="lt1"/>
+          </a:fontRef>
+        </p:style>
+        <p:txBody>
+          <a:bodyPr rtlCol="0" anchor="ctr"/>
+          <a:lstStyle/>
+          <a:p>
+            <a:pPr algn="ctr"/>
+          </a:p>
+        </p:txBody>
+      </p:sp>
+      <p:sp>
+        <p:nvSpPr>
+          <p:cNvPr id="8" name="TextBox 7"/>
+          <p:cNvSpPr txBox="1"/>
+          <p:nvPr/>
+        </p:nvSpPr>
+        <p:spPr>
+          <a:xfrm>
+            <a:off x="914400" y="4828032"/>
+            <a:ext cx="10332720" cy="1051560"/>
+          </a:xfrm>
+          <a:prstGeom prst="rect">
+            <a:avLst/>
+          </a:prstGeom>
+          <a:noFill/>
+        </p:spPr>
+        <p:txBody>
+          <a:bodyPr wrap="square" lIns="0" rIns="0" tIns="0" bIns="0" anchor="ctr">
+            <a:spAutoFit/>
+          </a:bodyPr>
+          <a:lstStyle/>
+          <a:p>
+            <a:pPr algn="l">
+              <a:spcBef>
+                <a:spcPts val="0"/>
+              </a:spcBef>
+              <a:spcAft>
+                <a:spcPts val="600"/>
+              </a:spcAft>
+              <a:buNone/>
+            </a:pPr>
+            <a:r>
+              <a:rPr sz="2000" b="1">
+                <a:solidFill>
+                  <a:srgbClr val="00998A"/>
+                </a:solidFill>
+                <a:latin typeface="Segoe UI Semibold"/>
+              </a:rPr>
+              <a:t>Speak → transcribe → understand → respond → speak</a:t>
+            </a:r>
+          </a:p>
+          <a:p>
+            <a:pPr algn="l">
+              <a:spcBef>
+                <a:spcPts val="0"/>
+              </a:spcBef>
+              <a:spcAft>
+                <a:spcPts val="0"/>
+              </a:spcAft>
+              <a:buNone/>
+            </a:pPr>
+            <a:r>
+              <a:rPr sz="1500" b="0">
+                <a:solidFill>
+                  <a:srgbClr val="103A5E"/>
+                </a:solidFill>
+                <a:latin typeface="Segoe UI"/>
+              </a:rPr>
+              <a:t>Every stage runs on the device, on hardware already in Windows. The ‘understand’ step is a drop-in AI extensibility point where you add on-device intelligence. Microsoft can deliver a full speech platform out of technology that already ships, no NPU and no cloud required.</a:t>
+            </a:r>
+          </a:p>
+        </p:txBody>
+      </p:sp>
+      <p:sp>
+        <p:nvSpPr>
+          <p:cNvPr id="9" name="TextBox 8"/>
+          <p:cNvSpPr txBox="1"/>
+          <p:nvPr/>
+        </p:nvSpPr>
+        <p:spPr>
+          <a:xfrm>
+            <a:off x="502920" y="6419088"/>
+            <a:ext cx="8229600" cy="320040"/>
+          </a:xfrm>
+          <a:prstGeom prst="rect">
+            <a:avLst/>
+          </a:prstGeom>
+          <a:noFill/>
+        </p:spPr>
+        <p:txBody>
+          <a:bodyPr wrap="square" lIns="0" rIns="0" tIns="0" bIns="0">
+            <a:spAutoFit/>
+          </a:bodyPr>
+          <a:lstStyle/>
+          <a:p>
+            <a:pPr algn="l">
+              <a:spcBef>
+                <a:spcPts val="0"/>
+              </a:spcBef>
+              <a:spcAft>
+                <a:spcPts val="0"/>
+              </a:spcAft>
+              <a:buNone/>
+            </a:pPr>
+            <a:r>
+              <a:rPr sz="1000" b="0">
+                <a:solidFill>
+                  <a:srgbClr val="606060"/>
+                </a:solidFill>
+                <a:latin typeface="Segoe UI"/>
+              </a:rPr>
+              <a:t>WindowsNaturalVoices  ·  on-device speech, offline</a:t>
+            </a:r>
+          </a:p>
+        </p:txBody>
+      </p:sp>
+      <p:sp>
+        <p:nvSpPr>
+          <p:cNvPr id="10" name="TextBox 9"/>
+          <p:cNvSpPr txBox="1"/>
+          <p:nvPr/>
+        </p:nvSpPr>
+        <p:spPr>
+          <a:xfrm>
+            <a:off x="11155680" y="6419088"/>
+            <a:ext cx="640080" cy="320040"/>
+          </a:xfrm>
+          <a:prstGeom prst="rect">
+            <a:avLst/>
+          </a:prstGeom>
+          <a:noFill/>
+        </p:spPr>
+        <p:txBody>
+          <a:bodyPr wrap="square" lIns="0" rIns="0" tIns="0" bIns="0">
+            <a:spAutoFit/>
+          </a:bodyPr>
+          <a:lstStyle/>
+          <a:p>
+            <a:pPr algn="r">
+              <a:spcBef>
+                <a:spcPts val="0"/>
+              </a:spcBef>
+              <a:spcAft>
+                <a:spcPts val="0"/>
+              </a:spcAft>
+              <a:buNone/>
+            </a:pPr>
+            <a:r>
+              <a:rPr sz="1000" b="0">
+                <a:solidFill>
+                  <a:srgbClr val="606060"/>
+                </a:solidFill>
+                <a:latin typeface="Segoe UI"/>
+              </a:rPr>
+              <a:t>12</a:t>
             </a:r>
           </a:p>
         </p:txBody>
@@ -5700,7 +5937,7 @@
             <a:avLst/>
           </a:prstGeom>
           <a:solidFill>
-            <a:srgbClr val="CA5F00"/>
+            <a:srgbClr val="0078D4"/>
           </a:solidFill>
           <a:ln>
             <a:noFill/>
@@ -5763,11 +6000,11 @@
             <a:r>
               <a:rPr sz="1300" b="1">
                 <a:solidFill>
-                  <a:srgbClr val="CA5F00"/>
+                  <a:srgbClr val="0078D4"/>
                 </a:solidFill>
                 <a:latin typeface="Segoe UI Semibold"/>
               </a:rPr>
-              <a:t>HOW · THE FRICTION TODAY</a:t>
+              <a:t>WHAT · PROOF (LISTENING)</a:t>
             </a:r>
           </a:p>
         </p:txBody>
@@ -5810,7 +6047,7 @@
                 </a:solidFill>
                 <a:latin typeface="Segoe UI Semibold"/>
               </a:rPr>
-              <a:t>It works, but only as a hack</a:t>
+              <a:t>On-device transcription at the quality tier, on the CPU</a:t>
             </a:r>
           </a:p>
         </p:txBody>
@@ -5823,8 +6060,8 @@
         </p:nvSpPr>
         <p:spPr>
           <a:xfrm>
-            <a:off x="640080" y="1828800"/>
-            <a:ext cx="10881360" cy="1280160"/>
+            <a:off x="640080" y="1600200"/>
+            <a:ext cx="10881360" cy="457200"/>
           </a:xfrm>
           <a:prstGeom prst="rect">
             <a:avLst/>
@@ -5842,124 +6079,38 @@
                 <a:spcPts val="0"/>
               </a:spcBef>
               <a:spcAft>
-                <a:spcPts val="1000"/>
-              </a:spcAft>
-              <a:buNone/>
-            </a:pPr>
-            <a:r>
-              <a:rPr sz="1700" b="0">
-                <a:solidFill>
-                  <a:srgbClr val="1F1F1F"/>
+                <a:spcPts val="0"/>
+              </a:spcAft>
+              <a:buNone/>
+            </a:pPr>
+            <a:r>
+              <a:rPr sz="1350" b="0">
+                <a:solidFill>
+                  <a:srgbClr val="606060"/>
                 </a:solidFill>
                 <a:latin typeface="Segoe UI"/>
               </a:rPr>
-              <a:t>To reach the on-device HD runtime with no public API, this reference implementation has to:</a:t>
-            </a:r>
-          </a:p>
-        </p:txBody>
-      </p:sp>
-      <p:sp>
-        <p:nvSpPr>
-          <p:cNvPr id="7" name="TextBox 6"/>
-          <p:cNvSpPr txBox="1"/>
-          <p:nvPr/>
-        </p:nvSpPr>
-        <p:spPr>
-          <a:xfrm>
-            <a:off x="914400" y="2880360"/>
-            <a:ext cx="10424160" cy="1737360"/>
-          </a:xfrm>
-          <a:prstGeom prst="rect">
-            <a:avLst/>
-          </a:prstGeom>
-          <a:noFill/>
-        </p:spPr>
-        <p:txBody>
-          <a:bodyPr wrap="square" lIns="0" rIns="0" tIns="0" bIns="0">
-            <a:spAutoFit/>
-          </a:bodyPr>
-          <a:lstStyle/>
-          <a:p>
-            <a:pPr algn="l">
-              <a:spcBef>
-                <a:spcPts val="0"/>
-              </a:spcBef>
-              <a:spcAft>
-                <a:spcPts val="1000"/>
-              </a:spcAft>
-              <a:buFont typeface="Segoe UI"/>
-              <a:buChar char="•"/>
-            </a:pPr>
-            <a:r>
-              <a:rPr sz="1700" b="0">
-                <a:solidFill>
-                  <a:srgbClr val="1F1F1F"/>
-                </a:solidFill>
-                <a:latin typeface="Segoe UI"/>
-              </a:rPr>
-              <a:t>Pass an undocumented Embedded Speech license string to unlock synthesis.</a:t>
-            </a:r>
-          </a:p>
-          <a:p>
-            <a:pPr algn="l">
-              <a:spcBef>
-                <a:spcPts val="0"/>
-              </a:spcBef>
-              <a:spcAft>
-                <a:spcPts val="1000"/>
-              </a:spcAft>
-              <a:buFont typeface="Segoe UI"/>
-              <a:buChar char="•"/>
-            </a:pPr>
-            <a:r>
-              <a:rPr sz="1700" b="0">
-                <a:solidFill>
-                  <a:srgbClr val="1F1F1F"/>
-                </a:solidFill>
-                <a:latin typeface="Segoe UI"/>
-              </a:rPr>
-              <a:t>Load gated extension DLLs out of a first-party SystemApps folder.</a:t>
-            </a:r>
-          </a:p>
-          <a:p>
-            <a:pPr algn="l">
-              <a:spcBef>
-                <a:spcPts val="0"/>
-              </a:spcBef>
-              <a:spcAft>
-                <a:spcPts val="1000"/>
-              </a:spcAft>
-              <a:buFont typeface="Segoe UI"/>
-              <a:buChar char="•"/>
-            </a:pPr>
-            <a:r>
-              <a:rPr sz="1700" b="0">
-                <a:solidFill>
-                  <a:srgbClr val="1F1F1F"/>
-                </a:solidFill>
-                <a:latin typeface="Segoe UI"/>
-              </a:rPr>
-              <a:t>Resolve native dependencies by walking the package graph by hand.</a:t>
-            </a:r>
-          </a:p>
-        </p:txBody>
-      </p:sp>
-      <p:sp>
-        <p:nvSpPr>
-          <p:cNvPr id="8" name="Rectangle 7"/>
+              <a:t>Real 58 s two-party mortgage call, normalized to a 2-leg call (one recognizer per speaker); single-stream engines doubled.</a:t>
+            </a:r>
+          </a:p>
+        </p:txBody>
+      </p:sp>
+      <p:sp>
+        <p:nvSpPr>
+          <p:cNvPr id="7" name="Rectangle 6"/>
           <p:cNvSpPr/>
           <p:nvPr/>
         </p:nvSpPr>
         <p:spPr>
           <a:xfrm>
-            <a:off x="640080" y="4892040"/>
-            <a:ext cx="10881360" cy="960120"/>
+            <a:off x="640080" y="2011680"/>
+            <a:ext cx="10881360" cy="457200"/>
           </a:xfrm>
           <a:prstGeom prst="rect">
             <a:avLst/>
           </a:prstGeom>
           <a:solidFill>
-            <a:srgbClr val="FBF0E6"/>
+            <a:srgbClr val="103A5E"/>
           </a:solidFill>
           <a:ln>
             <a:noFill/>
@@ -5990,14 +6141,14 @@
       </p:sp>
       <p:sp>
         <p:nvSpPr>
-          <p:cNvPr id="9" name="TextBox 8"/>
+          <p:cNvPr id="8" name="TextBox 7"/>
           <p:cNvSpPr txBox="1"/>
           <p:nvPr/>
         </p:nvSpPr>
         <p:spPr>
           <a:xfrm>
-            <a:off x="914400" y="5074920"/>
-            <a:ext cx="10332720" cy="685800"/>
+            <a:off x="731519" y="2011680"/>
+            <a:ext cx="3246120" cy="457200"/>
           </a:xfrm>
           <a:prstGeom prst="rect">
             <a:avLst/>
@@ -6020,13 +6171,56 @@
               <a:buNone/>
             </a:pPr>
             <a:r>
-              <a:rPr sz="1600" b="1">
-                <a:solidFill>
-                  <a:srgbClr val="CA5F00"/>
+              <a:rPr sz="1250" b="1">
+                <a:solidFill>
+                  <a:srgbClr val="FFFFFF"/>
                 </a:solidFill>
                 <a:latin typeface="Segoe UI Semibold"/>
               </a:rPr>
-              <a:t>Unsupported and fragile, exactly the friction that stops real products from shipping on the capability. That's what the API removes.</a:t>
+              <a:t>Engine</a:t>
+            </a:r>
+          </a:p>
+        </p:txBody>
+      </p:sp>
+      <p:sp>
+        <p:nvSpPr>
+          <p:cNvPr id="9" name="TextBox 8"/>
+          <p:cNvSpPr txBox="1"/>
+          <p:nvPr/>
+        </p:nvSpPr>
+        <p:spPr>
+          <a:xfrm>
+            <a:off x="4206240" y="2011680"/>
+            <a:ext cx="1097280" cy="457200"/>
+          </a:xfrm>
+          <a:prstGeom prst="rect">
+            <a:avLst/>
+          </a:prstGeom>
+          <a:noFill/>
+        </p:spPr>
+        <p:txBody>
+          <a:bodyPr wrap="square" lIns="0" rIns="0" tIns="0" bIns="0" anchor="ctr">
+            <a:spAutoFit/>
+          </a:bodyPr>
+          <a:lstStyle/>
+          <a:p>
+            <a:pPr algn="l">
+              <a:spcBef>
+                <a:spcPts val="0"/>
+              </a:spcBef>
+              <a:spcAft>
+                <a:spcPts val="0"/>
+              </a:spcAft>
+              <a:buNone/>
+            </a:pPr>
+            <a:r>
+              <a:rPr sz="1250" b="1">
+                <a:solidFill>
+                  <a:srgbClr val="FFFFFF"/>
+                </a:solidFill>
+                <a:latin typeface="Segoe UI Semibold"/>
+              </a:rPr>
+              <a:t>First final</a:t>
             </a:r>
           </a:p>
         </p:txBody>
@@ -6034,6 +6228,1561 @@
       <p:sp>
         <p:nvSpPr>
           <p:cNvPr id="10" name="TextBox 9"/>
+          <p:cNvSpPr txBox="1"/>
+          <p:nvPr/>
+        </p:nvSpPr>
+        <p:spPr>
+          <a:xfrm>
+            <a:off x="5532120" y="2011680"/>
+            <a:ext cx="1691640" cy="457200"/>
+          </a:xfrm>
+          <a:prstGeom prst="rect">
+            <a:avLst/>
+          </a:prstGeom>
+          <a:noFill/>
+        </p:spPr>
+        <p:txBody>
+          <a:bodyPr wrap="square" lIns="0" rIns="0" tIns="0" bIns="0" anchor="ctr">
+            <a:spAutoFit/>
+          </a:bodyPr>
+          <a:lstStyle/>
+          <a:p>
+            <a:pPr algn="l">
+              <a:spcBef>
+                <a:spcPts val="0"/>
+              </a:spcBef>
+              <a:spcAft>
+                <a:spcPts val="0"/>
+              </a:spcAft>
+              <a:buNone/>
+            </a:pPr>
+            <a:r>
+              <a:rPr sz="1250" b="1">
+                <a:solidFill>
+                  <a:srgbClr val="FFFFFF"/>
+                </a:solidFill>
+                <a:latin typeface="Segoe UI Semibold"/>
+              </a:rPr>
+              <a:t>Peak RAM (2 legs)</a:t>
+            </a:r>
+          </a:p>
+        </p:txBody>
+      </p:sp>
+      <p:sp>
+        <p:nvSpPr>
+          <p:cNvPr id="11" name="TextBox 10"/>
+          <p:cNvSpPr txBox="1"/>
+          <p:nvPr/>
+        </p:nvSpPr>
+        <p:spPr>
+          <a:xfrm>
+            <a:off x="7452360" y="2011680"/>
+            <a:ext cx="1280160" cy="457200"/>
+          </a:xfrm>
+          <a:prstGeom prst="rect">
+            <a:avLst/>
+          </a:prstGeom>
+          <a:noFill/>
+        </p:spPr>
+        <p:txBody>
+          <a:bodyPr wrap="square" lIns="0" rIns="0" tIns="0" bIns="0" anchor="ctr">
+            <a:spAutoFit/>
+          </a:bodyPr>
+          <a:lstStyle/>
+          <a:p>
+            <a:pPr algn="l">
+              <a:spcBef>
+                <a:spcPts val="0"/>
+              </a:spcBef>
+              <a:spcAft>
+                <a:spcPts val="0"/>
+              </a:spcAft>
+              <a:buNone/>
+            </a:pPr>
+            <a:r>
+              <a:rPr sz="1250" b="1">
+                <a:solidFill>
+                  <a:srgbClr val="FFFFFF"/>
+                </a:solidFill>
+                <a:latin typeface="Segoe UI Semibold"/>
+              </a:rPr>
+              <a:t>Hardware</a:t>
+            </a:r>
+          </a:p>
+        </p:txBody>
+      </p:sp>
+      <p:sp>
+        <p:nvSpPr>
+          <p:cNvPr id="12" name="TextBox 11"/>
+          <p:cNvSpPr txBox="1"/>
+          <p:nvPr/>
+        </p:nvSpPr>
+        <p:spPr>
+          <a:xfrm>
+            <a:off x="8915400" y="2011680"/>
+            <a:ext cx="2560320" cy="457200"/>
+          </a:xfrm>
+          <a:prstGeom prst="rect">
+            <a:avLst/>
+          </a:prstGeom>
+          <a:noFill/>
+        </p:spPr>
+        <p:txBody>
+          <a:bodyPr wrap="square" lIns="0" rIns="0" tIns="0" bIns="0" anchor="ctr">
+            <a:spAutoFit/>
+          </a:bodyPr>
+          <a:lstStyle/>
+          <a:p>
+            <a:pPr algn="l">
+              <a:spcBef>
+                <a:spcPts val="0"/>
+              </a:spcBef>
+              <a:spcAft>
+                <a:spcPts val="0"/>
+              </a:spcAft>
+              <a:buNone/>
+            </a:pPr>
+            <a:r>
+              <a:rPr sz="1250" b="1">
+                <a:solidFill>
+                  <a:srgbClr val="FFFFFF"/>
+                </a:solidFill>
+                <a:latin typeface="Segoe UI Semibold"/>
+              </a:rPr>
+              <a:t>Quality (numbers / ITN)</a:t>
+            </a:r>
+          </a:p>
+        </p:txBody>
+      </p:sp>
+      <p:sp>
+        <p:nvSpPr>
+          <p:cNvPr id="13" name="Rectangle 12"/>
+          <p:cNvSpPr/>
+          <p:nvPr/>
+        </p:nvSpPr>
+        <p:spPr>
+          <a:xfrm>
+            <a:off x="640080" y="2468880"/>
+            <a:ext cx="10881360" cy="512064"/>
+          </a:xfrm>
+          <a:prstGeom prst="rect">
+            <a:avLst/>
+          </a:prstGeom>
+          <a:solidFill>
+            <a:srgbClr val="E4F3F0"/>
+          </a:solidFill>
+          <a:ln>
+            <a:noFill/>
+          </a:ln>
+          <a:effectLst/>
+        </p:spPr>
+        <p:style>
+          <a:lnRef idx="1">
+            <a:schemeClr val="accent1"/>
+          </a:lnRef>
+          <a:fillRef idx="3">
+            <a:schemeClr val="accent1"/>
+          </a:fillRef>
+          <a:effectRef idx="2">
+            <a:schemeClr val="accent1"/>
+          </a:effectRef>
+          <a:fontRef idx="minor">
+            <a:schemeClr val="lt1"/>
+          </a:fontRef>
+        </p:style>
+        <p:txBody>
+          <a:bodyPr rtlCol="0" anchor="ctr"/>
+          <a:lstStyle/>
+          <a:p>
+            <a:pPr algn="ctr"/>
+          </a:p>
+        </p:txBody>
+      </p:sp>
+      <p:sp>
+        <p:nvSpPr>
+          <p:cNvPr id="14" name="Rectangle 13"/>
+          <p:cNvSpPr/>
+          <p:nvPr/>
+        </p:nvSpPr>
+        <p:spPr>
+          <a:xfrm>
+            <a:off x="640080" y="2468880"/>
+            <a:ext cx="91440" cy="512064"/>
+          </a:xfrm>
+          <a:prstGeom prst="rect">
+            <a:avLst/>
+          </a:prstGeom>
+          <a:solidFill>
+            <a:srgbClr val="00998A"/>
+          </a:solidFill>
+          <a:ln>
+            <a:noFill/>
+          </a:ln>
+          <a:effectLst/>
+        </p:spPr>
+        <p:style>
+          <a:lnRef idx="1">
+            <a:schemeClr val="accent1"/>
+          </a:lnRef>
+          <a:fillRef idx="3">
+            <a:schemeClr val="accent1"/>
+          </a:fillRef>
+          <a:effectRef idx="2">
+            <a:schemeClr val="accent1"/>
+          </a:effectRef>
+          <a:fontRef idx="minor">
+            <a:schemeClr val="lt1"/>
+          </a:fontRef>
+        </p:style>
+        <p:txBody>
+          <a:bodyPr rtlCol="0" anchor="ctr"/>
+          <a:lstStyle/>
+          <a:p>
+            <a:pPr algn="ctr"/>
+          </a:p>
+        </p:txBody>
+      </p:sp>
+      <p:sp>
+        <p:nvSpPr>
+          <p:cNvPr id="15" name="TextBox 14"/>
+          <p:cNvSpPr txBox="1"/>
+          <p:nvPr/>
+        </p:nvSpPr>
+        <p:spPr>
+          <a:xfrm>
+            <a:off x="731519" y="2468880"/>
+            <a:ext cx="3246120" cy="512064"/>
+          </a:xfrm>
+          <a:prstGeom prst="rect">
+            <a:avLst/>
+          </a:prstGeom>
+          <a:noFill/>
+        </p:spPr>
+        <p:txBody>
+          <a:bodyPr wrap="square" lIns="0" rIns="0" tIns="0" bIns="0" anchor="ctr">
+            <a:spAutoFit/>
+          </a:bodyPr>
+          <a:lstStyle/>
+          <a:p>
+            <a:pPr algn="l">
+              <a:spcBef>
+                <a:spcPts val="0"/>
+              </a:spcBef>
+              <a:spcAft>
+                <a:spcPts val="0"/>
+              </a:spcAft>
+              <a:buNone/>
+            </a:pPr>
+            <a:r>
+              <a:rPr sz="1250" b="1">
+                <a:solidFill>
+                  <a:srgbClr val="1F1F1F"/>
+                </a:solidFill>
+                <a:latin typeface="Segoe UI Semibold"/>
+              </a:rPr>
+              <a:t>Live Captions (this library)</a:t>
+            </a:r>
+          </a:p>
+        </p:txBody>
+      </p:sp>
+      <p:sp>
+        <p:nvSpPr>
+          <p:cNvPr id="16" name="TextBox 15"/>
+          <p:cNvSpPr txBox="1"/>
+          <p:nvPr/>
+        </p:nvSpPr>
+        <p:spPr>
+          <a:xfrm>
+            <a:off x="4206240" y="2468880"/>
+            <a:ext cx="1097280" cy="512064"/>
+          </a:xfrm>
+          <a:prstGeom prst="rect">
+            <a:avLst/>
+          </a:prstGeom>
+          <a:noFill/>
+        </p:spPr>
+        <p:txBody>
+          <a:bodyPr wrap="square" lIns="0" rIns="0" tIns="0" bIns="0" anchor="ctr">
+            <a:spAutoFit/>
+          </a:bodyPr>
+          <a:lstStyle/>
+          <a:p>
+            <a:pPr algn="l">
+              <a:spcBef>
+                <a:spcPts val="0"/>
+              </a:spcBef>
+              <a:spcAft>
+                <a:spcPts val="0"/>
+              </a:spcAft>
+              <a:buNone/>
+            </a:pPr>
+            <a:r>
+              <a:rPr sz="1250" b="0">
+                <a:solidFill>
+                  <a:srgbClr val="606060"/>
+                </a:solidFill>
+                <a:latin typeface="Segoe UI"/>
+              </a:rPr>
+              <a:t>~4 s</a:t>
+            </a:r>
+          </a:p>
+        </p:txBody>
+      </p:sp>
+      <p:sp>
+        <p:nvSpPr>
+          <p:cNvPr id="17" name="TextBox 16"/>
+          <p:cNvSpPr txBox="1"/>
+          <p:nvPr/>
+        </p:nvSpPr>
+        <p:spPr>
+          <a:xfrm>
+            <a:off x="5532120" y="2468880"/>
+            <a:ext cx="1691640" cy="512064"/>
+          </a:xfrm>
+          <a:prstGeom prst="rect">
+            <a:avLst/>
+          </a:prstGeom>
+          <a:noFill/>
+        </p:spPr>
+        <p:txBody>
+          <a:bodyPr wrap="square" lIns="0" rIns="0" tIns="0" bIns="0" anchor="ctr">
+            <a:spAutoFit/>
+          </a:bodyPr>
+          <a:lstStyle/>
+          <a:p>
+            <a:pPr algn="l">
+              <a:spcBef>
+                <a:spcPts val="0"/>
+              </a:spcBef>
+              <a:spcAft>
+                <a:spcPts val="0"/>
+              </a:spcAft>
+              <a:buNone/>
+            </a:pPr>
+            <a:r>
+              <a:rPr sz="1250" b="1">
+                <a:solidFill>
+                  <a:srgbClr val="0078D4"/>
+                </a:solidFill>
+                <a:latin typeface="Segoe UI Semibold"/>
+              </a:rPr>
+              <a:t>~500 MB</a:t>
+            </a:r>
+          </a:p>
+        </p:txBody>
+      </p:sp>
+      <p:sp>
+        <p:nvSpPr>
+          <p:cNvPr id="18" name="TextBox 17"/>
+          <p:cNvSpPr txBox="1"/>
+          <p:nvPr/>
+        </p:nvSpPr>
+        <p:spPr>
+          <a:xfrm>
+            <a:off x="7452360" y="2468880"/>
+            <a:ext cx="1280160" cy="512064"/>
+          </a:xfrm>
+          <a:prstGeom prst="rect">
+            <a:avLst/>
+          </a:prstGeom>
+          <a:noFill/>
+        </p:spPr>
+        <p:txBody>
+          <a:bodyPr wrap="square" lIns="0" rIns="0" tIns="0" bIns="0" anchor="ctr">
+            <a:spAutoFit/>
+          </a:bodyPr>
+          <a:lstStyle/>
+          <a:p>
+            <a:pPr algn="l">
+              <a:spcBef>
+                <a:spcPts val="0"/>
+              </a:spcBef>
+              <a:spcAft>
+                <a:spcPts val="0"/>
+              </a:spcAft>
+              <a:buNone/>
+            </a:pPr>
+            <a:r>
+              <a:rPr sz="1250" b="0">
+                <a:solidFill>
+                  <a:srgbClr val="606060"/>
+                </a:solidFill>
+                <a:latin typeface="Segoe UI"/>
+              </a:rPr>
+              <a:t>CPU</a:t>
+            </a:r>
+          </a:p>
+        </p:txBody>
+      </p:sp>
+      <p:sp>
+        <p:nvSpPr>
+          <p:cNvPr id="19" name="TextBox 18"/>
+          <p:cNvSpPr txBox="1"/>
+          <p:nvPr/>
+        </p:nvSpPr>
+        <p:spPr>
+          <a:xfrm>
+            <a:off x="8915400" y="2468880"/>
+            <a:ext cx="2560320" cy="512064"/>
+          </a:xfrm>
+          <a:prstGeom prst="rect">
+            <a:avLst/>
+          </a:prstGeom>
+          <a:noFill/>
+        </p:spPr>
+        <p:txBody>
+          <a:bodyPr wrap="square" lIns="0" rIns="0" tIns="0" bIns="0" anchor="ctr">
+            <a:spAutoFit/>
+          </a:bodyPr>
+          <a:lstStyle/>
+          <a:p>
+            <a:pPr algn="l">
+              <a:spcBef>
+                <a:spcPts val="0"/>
+              </a:spcBef>
+              <a:spcAft>
+                <a:spcPts val="0"/>
+              </a:spcAft>
+              <a:buNone/>
+            </a:pPr>
+            <a:r>
+              <a:rPr sz="1250" b="0">
+                <a:solidFill>
+                  <a:srgbClr val="606060"/>
+                </a:solidFill>
+                <a:latin typeface="Segoe UI"/>
+              </a:rPr>
+              <a:t>ITN tier ($ / % / currency)</a:t>
+            </a:r>
+          </a:p>
+        </p:txBody>
+      </p:sp>
+      <p:sp>
+        <p:nvSpPr>
+          <p:cNvPr id="20" name="Rectangle 19"/>
+          <p:cNvSpPr/>
+          <p:nvPr/>
+        </p:nvSpPr>
+        <p:spPr>
+          <a:xfrm>
+            <a:off x="640080" y="2980944"/>
+            <a:ext cx="10881360" cy="512064"/>
+          </a:xfrm>
+          <a:prstGeom prst="rect">
+            <a:avLst/>
+          </a:prstGeom>
+          <a:solidFill>
+            <a:srgbClr val="F3F6FB"/>
+          </a:solidFill>
+          <a:ln>
+            <a:noFill/>
+          </a:ln>
+          <a:effectLst/>
+        </p:spPr>
+        <p:style>
+          <a:lnRef idx="1">
+            <a:schemeClr val="accent1"/>
+          </a:lnRef>
+          <a:fillRef idx="3">
+            <a:schemeClr val="accent1"/>
+          </a:fillRef>
+          <a:effectRef idx="2">
+            <a:schemeClr val="accent1"/>
+          </a:effectRef>
+          <a:fontRef idx="minor">
+            <a:schemeClr val="lt1"/>
+          </a:fontRef>
+        </p:style>
+        <p:txBody>
+          <a:bodyPr rtlCol="0" anchor="ctr"/>
+          <a:lstStyle/>
+          <a:p>
+            <a:pPr algn="ctr"/>
+          </a:p>
+        </p:txBody>
+      </p:sp>
+      <p:sp>
+        <p:nvSpPr>
+          <p:cNvPr id="21" name="TextBox 20"/>
+          <p:cNvSpPr txBox="1"/>
+          <p:nvPr/>
+        </p:nvSpPr>
+        <p:spPr>
+          <a:xfrm>
+            <a:off x="731519" y="2980944"/>
+            <a:ext cx="3246120" cy="512064"/>
+          </a:xfrm>
+          <a:prstGeom prst="rect">
+            <a:avLst/>
+          </a:prstGeom>
+          <a:noFill/>
+        </p:spPr>
+        <p:txBody>
+          <a:bodyPr wrap="square" lIns="0" rIns="0" tIns="0" bIns="0" anchor="ctr">
+            <a:spAutoFit/>
+          </a:bodyPr>
+          <a:lstStyle/>
+          <a:p>
+            <a:pPr algn="l">
+              <a:spcBef>
+                <a:spcPts val="0"/>
+              </a:spcBef>
+              <a:spcAft>
+                <a:spcPts val="0"/>
+              </a:spcAft>
+              <a:buNone/>
+            </a:pPr>
+            <a:r>
+              <a:rPr sz="1250" b="1">
+                <a:solidFill>
+                  <a:srgbClr val="1F1F1F"/>
+                </a:solidFill>
+                <a:latin typeface="Segoe UI Semibold"/>
+              </a:rPr>
+              <a:t>Apple SpeechAnalyzer (macOS)</a:t>
+            </a:r>
+          </a:p>
+        </p:txBody>
+      </p:sp>
+      <p:sp>
+        <p:nvSpPr>
+          <p:cNvPr id="22" name="TextBox 21"/>
+          <p:cNvSpPr txBox="1"/>
+          <p:nvPr/>
+        </p:nvSpPr>
+        <p:spPr>
+          <a:xfrm>
+            <a:off x="4206240" y="2980944"/>
+            <a:ext cx="1097280" cy="512064"/>
+          </a:xfrm>
+          <a:prstGeom prst="rect">
+            <a:avLst/>
+          </a:prstGeom>
+          <a:noFill/>
+        </p:spPr>
+        <p:txBody>
+          <a:bodyPr wrap="square" lIns="0" rIns="0" tIns="0" bIns="0" anchor="ctr">
+            <a:spAutoFit/>
+          </a:bodyPr>
+          <a:lstStyle/>
+          <a:p>
+            <a:pPr algn="l">
+              <a:spcBef>
+                <a:spcPts val="0"/>
+              </a:spcBef>
+              <a:spcAft>
+                <a:spcPts val="0"/>
+              </a:spcAft>
+              <a:buNone/>
+            </a:pPr>
+            <a:r>
+              <a:rPr sz="1250" b="0">
+                <a:solidFill>
+                  <a:srgbClr val="606060"/>
+                </a:solidFill>
+                <a:latin typeface="Segoe UI"/>
+              </a:rPr>
+              <a:t>~4 s</a:t>
+            </a:r>
+          </a:p>
+        </p:txBody>
+      </p:sp>
+      <p:sp>
+        <p:nvSpPr>
+          <p:cNvPr id="23" name="TextBox 22"/>
+          <p:cNvSpPr txBox="1"/>
+          <p:nvPr/>
+        </p:nvSpPr>
+        <p:spPr>
+          <a:xfrm>
+            <a:off x="5532120" y="2980944"/>
+            <a:ext cx="1691640" cy="512064"/>
+          </a:xfrm>
+          <a:prstGeom prst="rect">
+            <a:avLst/>
+          </a:prstGeom>
+          <a:noFill/>
+        </p:spPr>
+        <p:txBody>
+          <a:bodyPr wrap="square" lIns="0" rIns="0" tIns="0" bIns="0" anchor="ctr">
+            <a:spAutoFit/>
+          </a:bodyPr>
+          <a:lstStyle/>
+          <a:p>
+            <a:pPr algn="l">
+              <a:spcBef>
+                <a:spcPts val="0"/>
+              </a:spcBef>
+              <a:spcAft>
+                <a:spcPts val="0"/>
+              </a:spcAft>
+              <a:buNone/>
+            </a:pPr>
+            <a:r>
+              <a:rPr sz="1250" b="1">
+                <a:solidFill>
+                  <a:srgbClr val="0078D4"/>
+                </a:solidFill>
+                <a:latin typeface="Segoe UI Semibold"/>
+              </a:rPr>
+              <a:t>~440 MB</a:t>
+            </a:r>
+          </a:p>
+        </p:txBody>
+      </p:sp>
+      <p:sp>
+        <p:nvSpPr>
+          <p:cNvPr id="24" name="TextBox 23"/>
+          <p:cNvSpPr txBox="1"/>
+          <p:nvPr/>
+        </p:nvSpPr>
+        <p:spPr>
+          <a:xfrm>
+            <a:off x="7452360" y="2980944"/>
+            <a:ext cx="1280160" cy="512064"/>
+          </a:xfrm>
+          <a:prstGeom prst="rect">
+            <a:avLst/>
+          </a:prstGeom>
+          <a:noFill/>
+        </p:spPr>
+        <p:txBody>
+          <a:bodyPr wrap="square" lIns="0" rIns="0" tIns="0" bIns="0" anchor="ctr">
+            <a:spAutoFit/>
+          </a:bodyPr>
+          <a:lstStyle/>
+          <a:p>
+            <a:pPr algn="l">
+              <a:spcBef>
+                <a:spcPts val="0"/>
+              </a:spcBef>
+              <a:spcAft>
+                <a:spcPts val="0"/>
+              </a:spcAft>
+              <a:buNone/>
+            </a:pPr>
+            <a:r>
+              <a:rPr sz="1250" b="0">
+                <a:solidFill>
+                  <a:srgbClr val="606060"/>
+                </a:solidFill>
+                <a:latin typeface="Segoe UI"/>
+              </a:rPr>
+              <a:t>Apple ANE</a:t>
+            </a:r>
+          </a:p>
+        </p:txBody>
+      </p:sp>
+      <p:sp>
+        <p:nvSpPr>
+          <p:cNvPr id="25" name="TextBox 24"/>
+          <p:cNvSpPr txBox="1"/>
+          <p:nvPr/>
+        </p:nvSpPr>
+        <p:spPr>
+          <a:xfrm>
+            <a:off x="8915400" y="2980944"/>
+            <a:ext cx="2560320" cy="512064"/>
+          </a:xfrm>
+          <a:prstGeom prst="rect">
+            <a:avLst/>
+          </a:prstGeom>
+          <a:noFill/>
+        </p:spPr>
+        <p:txBody>
+          <a:bodyPr wrap="square" lIns="0" rIns="0" tIns="0" bIns="0" anchor="ctr">
+            <a:spAutoFit/>
+          </a:bodyPr>
+          <a:lstStyle/>
+          <a:p>
+            <a:pPr algn="l">
+              <a:spcBef>
+                <a:spcPts val="0"/>
+              </a:spcBef>
+              <a:spcAft>
+                <a:spcPts val="0"/>
+              </a:spcAft>
+              <a:buNone/>
+            </a:pPr>
+            <a:r>
+              <a:rPr sz="1250" b="0">
+                <a:solidFill>
+                  <a:srgbClr val="606060"/>
+                </a:solidFill>
+                <a:latin typeface="Segoe UI"/>
+              </a:rPr>
+              <a:t>Reference: $610,000, 6.2%</a:t>
+            </a:r>
+          </a:p>
+        </p:txBody>
+      </p:sp>
+      <p:sp>
+        <p:nvSpPr>
+          <p:cNvPr id="26" name="Rectangle 25"/>
+          <p:cNvSpPr/>
+          <p:nvPr/>
+        </p:nvSpPr>
+        <p:spPr>
+          <a:xfrm>
+            <a:off x="640080" y="3493008"/>
+            <a:ext cx="10881360" cy="512064"/>
+          </a:xfrm>
+          <a:prstGeom prst="rect">
+            <a:avLst/>
+          </a:prstGeom>
+          <a:solidFill>
+            <a:srgbClr val="F3F6FB"/>
+          </a:solidFill>
+          <a:ln>
+            <a:noFill/>
+          </a:ln>
+          <a:effectLst/>
+        </p:spPr>
+        <p:style>
+          <a:lnRef idx="1">
+            <a:schemeClr val="accent1"/>
+          </a:lnRef>
+          <a:fillRef idx="3">
+            <a:schemeClr val="accent1"/>
+          </a:fillRef>
+          <a:effectRef idx="2">
+            <a:schemeClr val="accent1"/>
+          </a:effectRef>
+          <a:fontRef idx="minor">
+            <a:schemeClr val="lt1"/>
+          </a:fontRef>
+        </p:style>
+        <p:txBody>
+          <a:bodyPr rtlCol="0" anchor="ctr"/>
+          <a:lstStyle/>
+          <a:p>
+            <a:pPr algn="ctr"/>
+          </a:p>
+        </p:txBody>
+      </p:sp>
+      <p:sp>
+        <p:nvSpPr>
+          <p:cNvPr id="27" name="TextBox 26"/>
+          <p:cNvSpPr txBox="1"/>
+          <p:nvPr/>
+        </p:nvSpPr>
+        <p:spPr>
+          <a:xfrm>
+            <a:off x="731519" y="3493008"/>
+            <a:ext cx="3246120" cy="512064"/>
+          </a:xfrm>
+          <a:prstGeom prst="rect">
+            <a:avLst/>
+          </a:prstGeom>
+          <a:noFill/>
+        </p:spPr>
+        <p:txBody>
+          <a:bodyPr wrap="square" lIns="0" rIns="0" tIns="0" bIns="0" anchor="ctr">
+            <a:spAutoFit/>
+          </a:bodyPr>
+          <a:lstStyle/>
+          <a:p>
+            <a:pPr algn="l">
+              <a:spcBef>
+                <a:spcPts val="0"/>
+              </a:spcBef>
+              <a:spcAft>
+                <a:spcPts val="0"/>
+              </a:spcAft>
+              <a:buNone/>
+            </a:pPr>
+            <a:r>
+              <a:rPr sz="1250" b="1">
+                <a:solidFill>
+                  <a:srgbClr val="1F1F1F"/>
+                </a:solidFill>
+                <a:latin typeface="Segoe UI Semibold"/>
+              </a:rPr>
+              <a:t>WinAI Speech Preview</a:t>
+            </a:r>
+          </a:p>
+        </p:txBody>
+      </p:sp>
+      <p:sp>
+        <p:nvSpPr>
+          <p:cNvPr id="28" name="TextBox 27"/>
+          <p:cNvSpPr txBox="1"/>
+          <p:nvPr/>
+        </p:nvSpPr>
+        <p:spPr>
+          <a:xfrm>
+            <a:off x="4206240" y="3493008"/>
+            <a:ext cx="1097280" cy="512064"/>
+          </a:xfrm>
+          <a:prstGeom prst="rect">
+            <a:avLst/>
+          </a:prstGeom>
+          <a:noFill/>
+        </p:spPr>
+        <p:txBody>
+          <a:bodyPr wrap="square" lIns="0" rIns="0" tIns="0" bIns="0" anchor="ctr">
+            <a:spAutoFit/>
+          </a:bodyPr>
+          <a:lstStyle/>
+          <a:p>
+            <a:pPr algn="l">
+              <a:spcBef>
+                <a:spcPts val="0"/>
+              </a:spcBef>
+              <a:spcAft>
+                <a:spcPts val="0"/>
+              </a:spcAft>
+              <a:buNone/>
+            </a:pPr>
+            <a:r>
+              <a:rPr sz="1250" b="0">
+                <a:solidFill>
+                  <a:srgbClr val="606060"/>
+                </a:solidFill>
+                <a:latin typeface="Segoe UI"/>
+              </a:rPr>
+              <a:t>3.5 s</a:t>
+            </a:r>
+          </a:p>
+        </p:txBody>
+      </p:sp>
+      <p:sp>
+        <p:nvSpPr>
+          <p:cNvPr id="29" name="TextBox 28"/>
+          <p:cNvSpPr txBox="1"/>
+          <p:nvPr/>
+        </p:nvSpPr>
+        <p:spPr>
+          <a:xfrm>
+            <a:off x="5532120" y="3493008"/>
+            <a:ext cx="1691640" cy="512064"/>
+          </a:xfrm>
+          <a:prstGeom prst="rect">
+            <a:avLst/>
+          </a:prstGeom>
+          <a:noFill/>
+        </p:spPr>
+        <p:txBody>
+          <a:bodyPr wrap="square" lIns="0" rIns="0" tIns="0" bIns="0" anchor="ctr">
+            <a:spAutoFit/>
+          </a:bodyPr>
+          <a:lstStyle/>
+          <a:p>
+            <a:pPr algn="l">
+              <a:spcBef>
+                <a:spcPts val="0"/>
+              </a:spcBef>
+              <a:spcAft>
+                <a:spcPts val="0"/>
+              </a:spcAft>
+              <a:buNone/>
+            </a:pPr>
+            <a:r>
+              <a:rPr sz="1250" b="1">
+                <a:solidFill>
+                  <a:srgbClr val="0078D4"/>
+                </a:solidFill>
+                <a:latin typeface="Segoe UI Semibold"/>
+              </a:rPr>
+              <a:t>~6,400 MB</a:t>
+            </a:r>
+          </a:p>
+        </p:txBody>
+      </p:sp>
+      <p:sp>
+        <p:nvSpPr>
+          <p:cNvPr id="30" name="TextBox 29"/>
+          <p:cNvSpPr txBox="1"/>
+          <p:nvPr/>
+        </p:nvSpPr>
+        <p:spPr>
+          <a:xfrm>
+            <a:off x="7452360" y="3493008"/>
+            <a:ext cx="1280160" cy="512064"/>
+          </a:xfrm>
+          <a:prstGeom prst="rect">
+            <a:avLst/>
+          </a:prstGeom>
+          <a:noFill/>
+        </p:spPr>
+        <p:txBody>
+          <a:bodyPr wrap="square" lIns="0" rIns="0" tIns="0" bIns="0" anchor="ctr">
+            <a:spAutoFit/>
+          </a:bodyPr>
+          <a:lstStyle/>
+          <a:p>
+            <a:pPr algn="l">
+              <a:spcBef>
+                <a:spcPts val="0"/>
+              </a:spcBef>
+              <a:spcAft>
+                <a:spcPts val="0"/>
+              </a:spcAft>
+              <a:buNone/>
+            </a:pPr>
+            <a:r>
+              <a:rPr sz="1250" b="0">
+                <a:solidFill>
+                  <a:srgbClr val="606060"/>
+                </a:solidFill>
+                <a:latin typeface="Segoe UI"/>
+              </a:rPr>
+              <a:t>Hexagon NPU</a:t>
+            </a:r>
+          </a:p>
+        </p:txBody>
+      </p:sp>
+      <p:sp>
+        <p:nvSpPr>
+          <p:cNvPr id="31" name="TextBox 30"/>
+          <p:cNvSpPr txBox="1"/>
+          <p:nvPr/>
+        </p:nvSpPr>
+        <p:spPr>
+          <a:xfrm>
+            <a:off x="8915400" y="3493008"/>
+            <a:ext cx="2560320" cy="512064"/>
+          </a:xfrm>
+          <a:prstGeom prst="rect">
+            <a:avLst/>
+          </a:prstGeom>
+          <a:noFill/>
+        </p:spPr>
+        <p:txBody>
+          <a:bodyPr wrap="square" lIns="0" rIns="0" tIns="0" bIns="0" anchor="ctr">
+            <a:spAutoFit/>
+          </a:bodyPr>
+          <a:lstStyle/>
+          <a:p>
+            <a:pPr algn="l">
+              <a:spcBef>
+                <a:spcPts val="0"/>
+              </a:spcBef>
+              <a:spcAft>
+                <a:spcPts val="0"/>
+              </a:spcAft>
+              <a:buNone/>
+            </a:pPr>
+            <a:r>
+              <a:rPr sz="1250" b="0">
+                <a:solidFill>
+                  <a:srgbClr val="606060"/>
+                </a:solidFill>
+                <a:latin typeface="Segoe UI"/>
+              </a:rPr>
+              <a:t>Best ITN (Whisper Turbo)</a:t>
+            </a:r>
+          </a:p>
+        </p:txBody>
+      </p:sp>
+      <p:sp>
+        <p:nvSpPr>
+          <p:cNvPr id="32" name="Rectangle 31"/>
+          <p:cNvSpPr/>
+          <p:nvPr/>
+        </p:nvSpPr>
+        <p:spPr>
+          <a:xfrm>
+            <a:off x="640080" y="4005072"/>
+            <a:ext cx="10881360" cy="512064"/>
+          </a:xfrm>
+          <a:prstGeom prst="rect">
+            <a:avLst/>
+          </a:prstGeom>
+          <a:solidFill>
+            <a:srgbClr val="FFFFFF"/>
+          </a:solidFill>
+          <a:ln>
+            <a:noFill/>
+          </a:ln>
+          <a:effectLst/>
+        </p:spPr>
+        <p:style>
+          <a:lnRef idx="1">
+            <a:schemeClr val="accent1"/>
+          </a:lnRef>
+          <a:fillRef idx="3">
+            <a:schemeClr val="accent1"/>
+          </a:fillRef>
+          <a:effectRef idx="2">
+            <a:schemeClr val="accent1"/>
+          </a:effectRef>
+          <a:fontRef idx="minor">
+            <a:schemeClr val="lt1"/>
+          </a:fontRef>
+        </p:style>
+        <p:txBody>
+          <a:bodyPr rtlCol="0" anchor="ctr"/>
+          <a:lstStyle/>
+          <a:p>
+            <a:pPr algn="ctr"/>
+          </a:p>
+        </p:txBody>
+      </p:sp>
+      <p:sp>
+        <p:nvSpPr>
+          <p:cNvPr id="33" name="TextBox 32"/>
+          <p:cNvSpPr txBox="1"/>
+          <p:nvPr/>
+        </p:nvSpPr>
+        <p:spPr>
+          <a:xfrm>
+            <a:off x="731519" y="4005072"/>
+            <a:ext cx="3246120" cy="512064"/>
+          </a:xfrm>
+          <a:prstGeom prst="rect">
+            <a:avLst/>
+          </a:prstGeom>
+          <a:noFill/>
+        </p:spPr>
+        <p:txBody>
+          <a:bodyPr wrap="square" lIns="0" rIns="0" tIns="0" bIns="0" anchor="ctr">
+            <a:spAutoFit/>
+          </a:bodyPr>
+          <a:lstStyle/>
+          <a:p>
+            <a:pPr algn="l">
+              <a:spcBef>
+                <a:spcPts val="0"/>
+              </a:spcBef>
+              <a:spcAft>
+                <a:spcPts val="0"/>
+              </a:spcAft>
+              <a:buNone/>
+            </a:pPr>
+            <a:r>
+              <a:rPr sz="1250" b="1">
+                <a:solidFill>
+                  <a:srgbClr val="1F1F1F"/>
+                </a:solidFill>
+                <a:latin typeface="Segoe UI Semibold"/>
+              </a:rPr>
+              <a:t>Nemotron 0.6B (Foundry Local)</a:t>
+            </a:r>
+          </a:p>
+        </p:txBody>
+      </p:sp>
+      <p:sp>
+        <p:nvSpPr>
+          <p:cNvPr id="34" name="TextBox 33"/>
+          <p:cNvSpPr txBox="1"/>
+          <p:nvPr/>
+        </p:nvSpPr>
+        <p:spPr>
+          <a:xfrm>
+            <a:off x="4206240" y="4005072"/>
+            <a:ext cx="1097280" cy="512064"/>
+          </a:xfrm>
+          <a:prstGeom prst="rect">
+            <a:avLst/>
+          </a:prstGeom>
+          <a:noFill/>
+        </p:spPr>
+        <p:txBody>
+          <a:bodyPr wrap="square" lIns="0" rIns="0" tIns="0" bIns="0" anchor="ctr">
+            <a:spAutoFit/>
+          </a:bodyPr>
+          <a:lstStyle/>
+          <a:p>
+            <a:pPr algn="l">
+              <a:spcBef>
+                <a:spcPts val="0"/>
+              </a:spcBef>
+              <a:spcAft>
+                <a:spcPts val="0"/>
+              </a:spcAft>
+              <a:buNone/>
+            </a:pPr>
+            <a:r>
+              <a:rPr sz="1250" b="0">
+                <a:solidFill>
+                  <a:srgbClr val="606060"/>
+                </a:solidFill>
+                <a:latin typeface="Segoe UI"/>
+              </a:rPr>
+              <a:t>1.2 s</a:t>
+            </a:r>
+          </a:p>
+        </p:txBody>
+      </p:sp>
+      <p:sp>
+        <p:nvSpPr>
+          <p:cNvPr id="35" name="TextBox 34"/>
+          <p:cNvSpPr txBox="1"/>
+          <p:nvPr/>
+        </p:nvSpPr>
+        <p:spPr>
+          <a:xfrm>
+            <a:off x="5532120" y="4005072"/>
+            <a:ext cx="1691640" cy="512064"/>
+          </a:xfrm>
+          <a:prstGeom prst="rect">
+            <a:avLst/>
+          </a:prstGeom>
+          <a:noFill/>
+        </p:spPr>
+        <p:txBody>
+          <a:bodyPr wrap="square" lIns="0" rIns="0" tIns="0" bIns="0" anchor="ctr">
+            <a:spAutoFit/>
+          </a:bodyPr>
+          <a:lstStyle/>
+          <a:p>
+            <a:pPr algn="l">
+              <a:spcBef>
+                <a:spcPts val="0"/>
+              </a:spcBef>
+              <a:spcAft>
+                <a:spcPts val="0"/>
+              </a:spcAft>
+              <a:buNone/>
+            </a:pPr>
+            <a:r>
+              <a:rPr sz="1250" b="0">
+                <a:solidFill>
+                  <a:srgbClr val="606060"/>
+                </a:solidFill>
+                <a:latin typeface="Segoe UI"/>
+              </a:rPr>
+              <a:t>~1,750 MB</a:t>
+            </a:r>
+          </a:p>
+        </p:txBody>
+      </p:sp>
+      <p:sp>
+        <p:nvSpPr>
+          <p:cNvPr id="36" name="TextBox 35"/>
+          <p:cNvSpPr txBox="1"/>
+          <p:nvPr/>
+        </p:nvSpPr>
+        <p:spPr>
+          <a:xfrm>
+            <a:off x="7452360" y="4005072"/>
+            <a:ext cx="1280160" cy="512064"/>
+          </a:xfrm>
+          <a:prstGeom prst="rect">
+            <a:avLst/>
+          </a:prstGeom>
+          <a:noFill/>
+        </p:spPr>
+        <p:txBody>
+          <a:bodyPr wrap="square" lIns="0" rIns="0" tIns="0" bIns="0" anchor="ctr">
+            <a:spAutoFit/>
+          </a:bodyPr>
+          <a:lstStyle/>
+          <a:p>
+            <a:pPr algn="l">
+              <a:spcBef>
+                <a:spcPts val="0"/>
+              </a:spcBef>
+              <a:spcAft>
+                <a:spcPts val="0"/>
+              </a:spcAft>
+              <a:buNone/>
+            </a:pPr>
+            <a:r>
+              <a:rPr sz="1250" b="0">
+                <a:solidFill>
+                  <a:srgbClr val="606060"/>
+                </a:solidFill>
+                <a:latin typeface="Segoe UI"/>
+              </a:rPr>
+              <a:t>CPU</a:t>
+            </a:r>
+          </a:p>
+        </p:txBody>
+      </p:sp>
+      <p:sp>
+        <p:nvSpPr>
+          <p:cNvPr id="37" name="TextBox 36"/>
+          <p:cNvSpPr txBox="1"/>
+          <p:nvPr/>
+        </p:nvSpPr>
+        <p:spPr>
+          <a:xfrm>
+            <a:off x="8915400" y="4005072"/>
+            <a:ext cx="2560320" cy="512064"/>
+          </a:xfrm>
+          <a:prstGeom prst="rect">
+            <a:avLst/>
+          </a:prstGeom>
+          <a:noFill/>
+        </p:spPr>
+        <p:txBody>
+          <a:bodyPr wrap="square" lIns="0" rIns="0" tIns="0" bIns="0" anchor="ctr">
+            <a:spAutoFit/>
+          </a:bodyPr>
+          <a:lstStyle/>
+          <a:p>
+            <a:pPr algn="l">
+              <a:spcBef>
+                <a:spcPts val="0"/>
+              </a:spcBef>
+              <a:spcAft>
+                <a:spcPts val="0"/>
+              </a:spcAft>
+              <a:buNone/>
+            </a:pPr>
+            <a:r>
+              <a:rPr sz="1250" b="0">
+                <a:solidFill>
+                  <a:srgbClr val="606060"/>
+                </a:solidFill>
+                <a:latin typeface="Segoe UI"/>
+              </a:rPr>
+              <a:t>No clean sentence breaks</a:t>
+            </a:r>
+          </a:p>
+        </p:txBody>
+      </p:sp>
+      <p:sp>
+        <p:nvSpPr>
+          <p:cNvPr id="38" name="Rectangle 37"/>
+          <p:cNvSpPr/>
+          <p:nvPr/>
+        </p:nvSpPr>
+        <p:spPr>
+          <a:xfrm>
+            <a:off x="640080" y="4517136"/>
+            <a:ext cx="10881360" cy="512064"/>
+          </a:xfrm>
+          <a:prstGeom prst="rect">
+            <a:avLst/>
+          </a:prstGeom>
+          <a:solidFill>
+            <a:srgbClr val="FFFFFF"/>
+          </a:solidFill>
+          <a:ln>
+            <a:noFill/>
+          </a:ln>
+          <a:effectLst/>
+        </p:spPr>
+        <p:style>
+          <a:lnRef idx="1">
+            <a:schemeClr val="accent1"/>
+          </a:lnRef>
+          <a:fillRef idx="3">
+            <a:schemeClr val="accent1"/>
+          </a:fillRef>
+          <a:effectRef idx="2">
+            <a:schemeClr val="accent1"/>
+          </a:effectRef>
+          <a:fontRef idx="minor">
+            <a:schemeClr val="lt1"/>
+          </a:fontRef>
+        </p:style>
+        <p:txBody>
+          <a:bodyPr rtlCol="0" anchor="ctr"/>
+          <a:lstStyle/>
+          <a:p>
+            <a:pPr algn="ctr"/>
+          </a:p>
+        </p:txBody>
+      </p:sp>
+      <p:sp>
+        <p:nvSpPr>
+          <p:cNvPr id="39" name="TextBox 38"/>
+          <p:cNvSpPr txBox="1"/>
+          <p:nvPr/>
+        </p:nvSpPr>
+        <p:spPr>
+          <a:xfrm>
+            <a:off x="731519" y="4517136"/>
+            <a:ext cx="3246120" cy="512064"/>
+          </a:xfrm>
+          <a:prstGeom prst="rect">
+            <a:avLst/>
+          </a:prstGeom>
+          <a:noFill/>
+        </p:spPr>
+        <p:txBody>
+          <a:bodyPr wrap="square" lIns="0" rIns="0" tIns="0" bIns="0" anchor="ctr">
+            <a:spAutoFit/>
+          </a:bodyPr>
+          <a:lstStyle/>
+          <a:p>
+            <a:pPr algn="l">
+              <a:spcBef>
+                <a:spcPts val="0"/>
+              </a:spcBef>
+              <a:spcAft>
+                <a:spcPts val="0"/>
+              </a:spcAft>
+              <a:buNone/>
+            </a:pPr>
+            <a:r>
+              <a:rPr sz="1250" b="1">
+                <a:solidFill>
+                  <a:srgbClr val="1F1F1F"/>
+                </a:solidFill>
+                <a:latin typeface="Segoe UI Semibold"/>
+              </a:rPr>
+              <a:t>Whisper small (CPU ONNX)</a:t>
+            </a:r>
+          </a:p>
+        </p:txBody>
+      </p:sp>
+      <p:sp>
+        <p:nvSpPr>
+          <p:cNvPr id="40" name="TextBox 39"/>
+          <p:cNvSpPr txBox="1"/>
+          <p:nvPr/>
+        </p:nvSpPr>
+        <p:spPr>
+          <a:xfrm>
+            <a:off x="4206240" y="4517136"/>
+            <a:ext cx="1097280" cy="512064"/>
+          </a:xfrm>
+          <a:prstGeom prst="rect">
+            <a:avLst/>
+          </a:prstGeom>
+          <a:noFill/>
+        </p:spPr>
+        <p:txBody>
+          <a:bodyPr wrap="square" lIns="0" rIns="0" tIns="0" bIns="0" anchor="ctr">
+            <a:spAutoFit/>
+          </a:bodyPr>
+          <a:lstStyle/>
+          <a:p>
+            <a:pPr algn="l">
+              <a:spcBef>
+                <a:spcPts val="0"/>
+              </a:spcBef>
+              <a:spcAft>
+                <a:spcPts val="0"/>
+              </a:spcAft>
+              <a:buNone/>
+            </a:pPr>
+            <a:r>
+              <a:rPr sz="1250" b="0">
+                <a:solidFill>
+                  <a:srgbClr val="606060"/>
+                </a:solidFill>
+                <a:latin typeface="Segoe UI"/>
+              </a:rPr>
+              <a:t>2.3 s</a:t>
+            </a:r>
+          </a:p>
+        </p:txBody>
+      </p:sp>
+      <p:sp>
+        <p:nvSpPr>
+          <p:cNvPr id="41" name="TextBox 40"/>
+          <p:cNvSpPr txBox="1"/>
+          <p:nvPr/>
+        </p:nvSpPr>
+        <p:spPr>
+          <a:xfrm>
+            <a:off x="5532120" y="4517136"/>
+            <a:ext cx="1691640" cy="512064"/>
+          </a:xfrm>
+          <a:prstGeom prst="rect">
+            <a:avLst/>
+          </a:prstGeom>
+          <a:noFill/>
+        </p:spPr>
+        <p:txBody>
+          <a:bodyPr wrap="square" lIns="0" rIns="0" tIns="0" bIns="0" anchor="ctr">
+            <a:spAutoFit/>
+          </a:bodyPr>
+          <a:lstStyle/>
+          <a:p>
+            <a:pPr algn="l">
+              <a:spcBef>
+                <a:spcPts val="0"/>
+              </a:spcBef>
+              <a:spcAft>
+                <a:spcPts val="0"/>
+              </a:spcAft>
+              <a:buNone/>
+            </a:pPr>
+            <a:r>
+              <a:rPr sz="1250" b="0">
+                <a:solidFill>
+                  <a:srgbClr val="606060"/>
+                </a:solidFill>
+                <a:latin typeface="Segoe UI"/>
+              </a:rPr>
+              <a:t>~1,200 MB</a:t>
+            </a:r>
+          </a:p>
+        </p:txBody>
+      </p:sp>
+      <p:sp>
+        <p:nvSpPr>
+          <p:cNvPr id="42" name="TextBox 41"/>
+          <p:cNvSpPr txBox="1"/>
+          <p:nvPr/>
+        </p:nvSpPr>
+        <p:spPr>
+          <a:xfrm>
+            <a:off x="7452360" y="4517136"/>
+            <a:ext cx="1280160" cy="512064"/>
+          </a:xfrm>
+          <a:prstGeom prst="rect">
+            <a:avLst/>
+          </a:prstGeom>
+          <a:noFill/>
+        </p:spPr>
+        <p:txBody>
+          <a:bodyPr wrap="square" lIns="0" rIns="0" tIns="0" bIns="0" anchor="ctr">
+            <a:spAutoFit/>
+          </a:bodyPr>
+          <a:lstStyle/>
+          <a:p>
+            <a:pPr algn="l">
+              <a:spcBef>
+                <a:spcPts val="0"/>
+              </a:spcBef>
+              <a:spcAft>
+                <a:spcPts val="0"/>
+              </a:spcAft>
+              <a:buNone/>
+            </a:pPr>
+            <a:r>
+              <a:rPr sz="1250" b="0">
+                <a:solidFill>
+                  <a:srgbClr val="606060"/>
+                </a:solidFill>
+                <a:latin typeface="Segoe UI"/>
+              </a:rPr>
+              <a:t>CPU</a:t>
+            </a:r>
+          </a:p>
+        </p:txBody>
+      </p:sp>
+      <p:sp>
+        <p:nvSpPr>
+          <p:cNvPr id="43" name="TextBox 42"/>
+          <p:cNvSpPr txBox="1"/>
+          <p:nvPr/>
+        </p:nvSpPr>
+        <p:spPr>
+          <a:xfrm>
+            <a:off x="8915400" y="4517136"/>
+            <a:ext cx="2560320" cy="512064"/>
+          </a:xfrm>
+          <a:prstGeom prst="rect">
+            <a:avLst/>
+          </a:prstGeom>
+          <a:noFill/>
+        </p:spPr>
+        <p:txBody>
+          <a:bodyPr wrap="square" lIns="0" rIns="0" tIns="0" bIns="0" anchor="ctr">
+            <a:spAutoFit/>
+          </a:bodyPr>
+          <a:lstStyle/>
+          <a:p>
+            <a:pPr algn="l">
+              <a:spcBef>
+                <a:spcPts val="0"/>
+              </a:spcBef>
+              <a:spcAft>
+                <a:spcPts val="0"/>
+              </a:spcAft>
+              <a:buNone/>
+            </a:pPr>
+            <a:r>
+              <a:rPr sz="1250" b="0">
+                <a:solidFill>
+                  <a:srgbClr val="606060"/>
+                </a:solidFill>
+                <a:latin typeface="Segoe UI"/>
+              </a:rPr>
+              <a:t>Low: hallucinates numbers</a:t>
+            </a:r>
+          </a:p>
+        </p:txBody>
+      </p:sp>
+      <p:sp>
+        <p:nvSpPr>
+          <p:cNvPr id="44" name="Rectangle 43"/>
+          <p:cNvSpPr/>
+          <p:nvPr/>
+        </p:nvSpPr>
+        <p:spPr>
+          <a:xfrm>
+            <a:off x="640080" y="5138928"/>
+            <a:ext cx="10881360" cy="960120"/>
+          </a:xfrm>
+          <a:prstGeom prst="rect">
+            <a:avLst/>
+          </a:prstGeom>
+          <a:solidFill>
+            <a:srgbClr val="EAF1FB"/>
+          </a:solidFill>
+          <a:ln>
+            <a:noFill/>
+          </a:ln>
+          <a:effectLst/>
+        </p:spPr>
+        <p:style>
+          <a:lnRef idx="1">
+            <a:schemeClr val="accent1"/>
+          </a:lnRef>
+          <a:fillRef idx="3">
+            <a:schemeClr val="accent1"/>
+          </a:fillRef>
+          <a:effectRef idx="2">
+            <a:schemeClr val="accent1"/>
+          </a:effectRef>
+          <a:fontRef idx="minor">
+            <a:schemeClr val="lt1"/>
+          </a:fontRef>
+        </p:style>
+        <p:txBody>
+          <a:bodyPr rtlCol="0" anchor="ctr"/>
+          <a:lstStyle/>
+          <a:p>
+            <a:pPr algn="ctr"/>
+          </a:p>
+        </p:txBody>
+      </p:sp>
+      <p:sp>
+        <p:nvSpPr>
+          <p:cNvPr id="45" name="TextBox 44"/>
+          <p:cNvSpPr txBox="1"/>
+          <p:nvPr/>
+        </p:nvSpPr>
+        <p:spPr>
+          <a:xfrm>
+            <a:off x="914400" y="5285232"/>
+            <a:ext cx="10332720" cy="685800"/>
+          </a:xfrm>
+          <a:prstGeom prst="rect">
+            <a:avLst/>
+          </a:prstGeom>
+          <a:noFill/>
+        </p:spPr>
+        <p:txBody>
+          <a:bodyPr wrap="square" lIns="0" rIns="0" tIns="0" bIns="0" anchor="ctr">
+            <a:spAutoFit/>
+          </a:bodyPr>
+          <a:lstStyle/>
+          <a:p>
+            <a:pPr algn="l">
+              <a:spcBef>
+                <a:spcPts val="0"/>
+              </a:spcBef>
+              <a:spcAft>
+                <a:spcPts val="0"/>
+              </a:spcAft>
+              <a:buNone/>
+            </a:pPr>
+            <a:r>
+              <a:rPr sz="1450" b="1">
+                <a:solidFill>
+                  <a:srgbClr val="103A5E"/>
+                </a:solidFill>
+                <a:latin typeface="Segoe UI Semibold"/>
+              </a:rPr>
+              <a:t>The quality peers are Apple and NPU Whisper Turbo. This library matches that ITN tier on the CPU at ~500 MB for two legs: ~13× less RAM than the NPU path, no NPU. Nemotron and Whisper small are ruled out on quality, not memory.</a:t>
+            </a:r>
+          </a:p>
+        </p:txBody>
+      </p:sp>
+      <p:sp>
+        <p:nvSpPr>
+          <p:cNvPr id="46" name="TextBox 45"/>
           <p:cNvSpPr txBox="1"/>
           <p:nvPr/>
         </p:nvSpPr>
@@ -6069,14 +7818,14 @@
                 </a:solidFill>
                 <a:latin typeface="Segoe UI"/>
               </a:rPr>
-              <a:t>WindowsNaturalVoices  ·  on-device HD voices, offline</a:t>
-            </a:r>
-          </a:p>
-        </p:txBody>
-      </p:sp>
-      <p:sp>
-        <p:nvSpPr>
-          <p:cNvPr id="11" name="TextBox 10"/>
+              <a:t>WindowsNaturalVoices  ·  on-device speech, offline</a:t>
+            </a:r>
+          </a:p>
+        </p:txBody>
+      </p:sp>
+      <p:sp>
+        <p:nvSpPr>
+          <p:cNvPr id="47" name="TextBox 46"/>
           <p:cNvSpPr txBox="1"/>
           <p:nvPr/>
         </p:nvSpPr>
@@ -6150,7 +7899,7 @@
             <a:avLst/>
           </a:prstGeom>
           <a:solidFill>
-            <a:srgbClr val="F3F6FB"/>
+            <a:srgbClr val="103A5E"/>
           </a:solidFill>
           <a:ln>
             <a:noFill/>
@@ -6188,13 +7937,13 @@
         <p:spPr>
           <a:xfrm>
             <a:off x="0" y="0"/>
-            <a:ext cx="12191695" cy="146304"/>
+            <a:ext cx="12191695" cy="201168"/>
           </a:xfrm>
           <a:prstGeom prst="rect">
             <a:avLst/>
           </a:prstGeom>
           <a:solidFill>
-            <a:srgbClr val="0078D4"/>
+            <a:srgbClr val="CA5F00"/>
           </a:solidFill>
           <a:ln>
             <a:noFill/>
@@ -6225,146 +7974,14 @@
       </p:sp>
       <p:sp>
         <p:nvSpPr>
-          <p:cNvPr id="4" name="TextBox 3"/>
-          <p:cNvSpPr txBox="1"/>
-          <p:nvPr/>
-        </p:nvSpPr>
-        <p:spPr>
-          <a:xfrm>
-            <a:off x="502920" y="411480"/>
-            <a:ext cx="11155680" cy="365760"/>
-          </a:xfrm>
-          <a:prstGeom prst="rect">
-            <a:avLst/>
-          </a:prstGeom>
-          <a:noFill/>
-        </p:spPr>
-        <p:txBody>
-          <a:bodyPr wrap="square" lIns="0" rIns="0" tIns="0" bIns="0">
-            <a:spAutoFit/>
-          </a:bodyPr>
-          <a:lstStyle/>
-          <a:p>
-            <a:pPr algn="l">
-              <a:spcBef>
-                <a:spcPts val="0"/>
-              </a:spcBef>
-              <a:spcAft>
-                <a:spcPts val="0"/>
-              </a:spcAft>
-              <a:buNone/>
-            </a:pPr>
-            <a:r>
-              <a:rPr sz="1300" b="1">
-                <a:solidFill>
-                  <a:srgbClr val="0078D4"/>
-                </a:solidFill>
-                <a:latin typeface="Segoe UI Semibold"/>
-              </a:rPr>
-              <a:t>HOW · THE DESIGN</a:t>
-            </a:r>
-          </a:p>
-        </p:txBody>
-      </p:sp>
-      <p:sp>
-        <p:nvSpPr>
-          <p:cNvPr id="5" name="TextBox 4"/>
-          <p:cNvSpPr txBox="1"/>
-          <p:nvPr/>
-        </p:nvSpPr>
-        <p:spPr>
-          <a:xfrm>
-            <a:off x="502920" y="777240"/>
-            <a:ext cx="11155680" cy="914400"/>
-          </a:xfrm>
-          <a:prstGeom prst="rect">
-            <a:avLst/>
-          </a:prstGeom>
-          <a:noFill/>
-        </p:spPr>
-        <p:txBody>
-          <a:bodyPr wrap="square" lIns="0" rIns="0" tIns="0" bIns="0">
-            <a:spAutoFit/>
-          </a:bodyPr>
-          <a:lstStyle/>
-          <a:p>
-            <a:pPr algn="l">
-              <a:spcBef>
-                <a:spcPts val="0"/>
-              </a:spcBef>
-              <a:spcAft>
-                <a:spcPts val="0"/>
-              </a:spcAft>
-              <a:buNone/>
-            </a:pPr>
-            <a:r>
-              <a:rPr sz="3000" b="1">
-                <a:solidFill>
-                  <a:srgbClr val="1F1F1F"/>
-                </a:solidFill>
-                <a:latin typeface="Segoe UI Semibold"/>
-              </a:rPr>
-              <a:t>One API. Local by default. Cloud when you want it.</a:t>
-            </a:r>
-          </a:p>
-        </p:txBody>
-      </p:sp>
-      <p:sp>
-        <p:nvSpPr>
-          <p:cNvPr id="6" name="Rectangle 5"/>
+          <p:cNvPr id="4" name="Rectangle 3"/>
           <p:cNvSpPr/>
           <p:nvPr/>
         </p:nvSpPr>
         <p:spPr>
           <a:xfrm>
-            <a:off x="658368" y="1874519"/>
-            <a:ext cx="5257800" cy="2743200"/>
-          </a:xfrm>
-          <a:prstGeom prst="rect">
-            <a:avLst/>
-          </a:prstGeom>
-          <a:solidFill>
-            <a:srgbClr val="FFFFFF"/>
-          </a:solidFill>
-          <a:ln w="12700">
-            <a:solidFill>
-              <a:srgbClr val="D9E4F0"/>
-            </a:solidFill>
-          </a:ln>
-          <a:effectLst/>
-        </p:spPr>
-        <p:style>
-          <a:lnRef idx="1">
-            <a:schemeClr val="accent1"/>
-          </a:lnRef>
-          <a:fillRef idx="3">
-            <a:schemeClr val="accent1"/>
-          </a:fillRef>
-          <a:effectRef idx="2">
-            <a:schemeClr val="accent1"/>
-          </a:effectRef>
-          <a:fontRef idx="minor">
-            <a:schemeClr val="lt1"/>
-          </a:fontRef>
-        </p:style>
-        <p:txBody>
-          <a:bodyPr rtlCol="0" anchor="ctr"/>
-          <a:lstStyle/>
-          <a:p>
-            <a:pPr algn="ctr"/>
-          </a:p>
-        </p:txBody>
-      </p:sp>
-      <p:sp>
-        <p:nvSpPr>
-          <p:cNvPr id="7" name="Rectangle 6"/>
-          <p:cNvSpPr/>
-          <p:nvPr/>
-        </p:nvSpPr>
-        <p:spPr>
-          <a:xfrm>
-            <a:off x="658368" y="1874519"/>
-            <a:ext cx="5257800" cy="566928"/>
+            <a:off x="777240" y="3566160"/>
+            <a:ext cx="1371600" cy="82296"/>
           </a:xfrm>
           <a:prstGeom prst="rect">
             <a:avLst/>
@@ -6401,14 +8018,14 @@
       </p:sp>
       <p:sp>
         <p:nvSpPr>
-          <p:cNvPr id="8" name="TextBox 7"/>
+          <p:cNvPr id="5" name="TextBox 4"/>
           <p:cNvSpPr txBox="1"/>
           <p:nvPr/>
         </p:nvSpPr>
         <p:spPr>
           <a:xfrm>
-            <a:off x="950976" y="1984248"/>
-            <a:ext cx="4663440" cy="457200"/>
+            <a:off x="777240" y="2331720"/>
+            <a:ext cx="10607040" cy="640080"/>
           </a:xfrm>
           <a:prstGeom prst="rect">
             <a:avLst/>
@@ -6431,27 +8048,27 @@
               <a:buNone/>
             </a:pPr>
             <a:r>
-              <a:rPr sz="1600" b="1">
-                <a:solidFill>
-                  <a:srgbClr val="FFFFFF"/>
+              <a:rPr sz="2200" b="1">
+                <a:solidFill>
+                  <a:srgbClr val="00998A"/>
                 </a:solidFill>
                 <a:latin typeface="Segoe UI Semibold"/>
               </a:rPr>
-              <a:t>DEFAULT: on-device</a:t>
-            </a:r>
-          </a:p>
-        </p:txBody>
-      </p:sp>
-      <p:sp>
-        <p:nvSpPr>
-          <p:cNvPr id="9" name="TextBox 8"/>
+              <a:t>HOW</a:t>
+            </a:r>
+          </a:p>
+        </p:txBody>
+      </p:sp>
+      <p:sp>
+        <p:nvSpPr>
+          <p:cNvPr id="6" name="TextBox 5"/>
           <p:cNvSpPr txBox="1"/>
           <p:nvPr/>
         </p:nvSpPr>
         <p:spPr>
           <a:xfrm>
-            <a:off x="950976" y="2651760"/>
-            <a:ext cx="4663440" cy="1828800"/>
+            <a:off x="777240" y="3886200"/>
+            <a:ext cx="10607040" cy="2011680"/>
           </a:xfrm>
           <a:prstGeom prst="rect">
             <a:avLst/>
@@ -6469,497 +8086,38 @@
                 <a:spcPts val="0"/>
               </a:spcBef>
               <a:spcAft>
-                <a:spcPts val="900"/>
-              </a:spcAft>
-              <a:buFont typeface="Segoe UI"/>
-              <a:buChar char="•"/>
-            </a:pPr>
-            <a:r>
-              <a:rPr sz="1500" b="0">
-                <a:solidFill>
-                  <a:srgbClr val="1F1F1F"/>
-                </a:solidFill>
-                <a:latin typeface="Segoe UI"/>
-              </a:rPr>
-              <a:t>Offline, private, free, instant.</a:t>
-            </a:r>
-          </a:p>
-          <a:p>
-            <a:pPr algn="l">
-              <a:spcBef>
-                <a:spcPts val="0"/>
-              </a:spcBef>
-              <a:spcAft>
-                <a:spcPts val="900"/>
-              </a:spcAft>
-              <a:buFont typeface="Segoe UI"/>
-              <a:buChar char="•"/>
-            </a:pPr>
-            <a:r>
-              <a:rPr sz="1500" b="0">
-                <a:solidFill>
-                  <a:srgbClr val="1F1F1F"/>
-                </a:solidFill>
-                <a:latin typeface="Segoe UI"/>
-              </a:rPr>
-              <a:t>Runs on the installed Natural HD voice.</a:t>
-            </a:r>
-          </a:p>
-          <a:p>
-            <a:pPr algn="l">
-              <a:spcBef>
-                <a:spcPts val="0"/>
-              </a:spcBef>
-              <a:spcAft>
-                <a:spcPts val="900"/>
-              </a:spcAft>
-              <a:buFont typeface="Segoe UI"/>
-              <a:buChar char="•"/>
-            </a:pPr>
-            <a:r>
-              <a:rPr sz="1500" b="0">
-                <a:solidFill>
-                  <a:srgbClr val="1F1F1F"/>
-                </a:solidFill>
-                <a:latin typeface="Segoe UI"/>
-              </a:rPr>
-              <a:t>No key, no bill, nothing leaves the device.</a:t>
-            </a:r>
-          </a:p>
-        </p:txBody>
-      </p:sp>
-      <p:sp>
-        <p:nvSpPr>
-          <p:cNvPr id="10" name="Rectangle 9"/>
-          <p:cNvSpPr/>
-          <p:nvPr/>
-        </p:nvSpPr>
-        <p:spPr>
-          <a:xfrm>
-            <a:off x="6272784" y="1874519"/>
-            <a:ext cx="5257800" cy="2743200"/>
-          </a:xfrm>
-          <a:prstGeom prst="rect">
-            <a:avLst/>
-          </a:prstGeom>
-          <a:solidFill>
-            <a:srgbClr val="FFFFFF"/>
-          </a:solidFill>
-          <a:ln w="12700">
-            <a:solidFill>
-              <a:srgbClr val="D9E4F0"/>
-            </a:solidFill>
-          </a:ln>
-          <a:effectLst/>
-        </p:spPr>
-        <p:style>
-          <a:lnRef idx="1">
-            <a:schemeClr val="accent1"/>
-          </a:lnRef>
-          <a:fillRef idx="3">
-            <a:schemeClr val="accent1"/>
-          </a:fillRef>
-          <a:effectRef idx="2">
-            <a:schemeClr val="accent1"/>
-          </a:effectRef>
-          <a:fontRef idx="minor">
-            <a:schemeClr val="lt1"/>
-          </a:fontRef>
-        </p:style>
-        <p:txBody>
-          <a:bodyPr rtlCol="0" anchor="ctr"/>
-          <a:lstStyle/>
-          <a:p>
-            <a:pPr algn="ctr"/>
-          </a:p>
-        </p:txBody>
-      </p:sp>
-      <p:sp>
-        <p:nvSpPr>
-          <p:cNvPr id="11" name="Rectangle 10"/>
-          <p:cNvSpPr/>
-          <p:nvPr/>
-        </p:nvSpPr>
-        <p:spPr>
-          <a:xfrm>
-            <a:off x="6272784" y="1874519"/>
-            <a:ext cx="5257800" cy="566928"/>
-          </a:xfrm>
-          <a:prstGeom prst="rect">
-            <a:avLst/>
-          </a:prstGeom>
-          <a:solidFill>
-            <a:srgbClr val="0078D4"/>
-          </a:solidFill>
-          <a:ln>
-            <a:noFill/>
-          </a:ln>
-          <a:effectLst/>
-        </p:spPr>
-        <p:style>
-          <a:lnRef idx="1">
-            <a:schemeClr val="accent1"/>
-          </a:lnRef>
-          <a:fillRef idx="3">
-            <a:schemeClr val="accent1"/>
-          </a:fillRef>
-          <a:effectRef idx="2">
-            <a:schemeClr val="accent1"/>
-          </a:effectRef>
-          <a:fontRef idx="minor">
-            <a:schemeClr val="lt1"/>
-          </a:fontRef>
-        </p:style>
-        <p:txBody>
-          <a:bodyPr rtlCol="0" anchor="ctr"/>
-          <a:lstStyle/>
-          <a:p>
-            <a:pPr algn="ctr"/>
-          </a:p>
-        </p:txBody>
-      </p:sp>
-      <p:sp>
-        <p:nvSpPr>
-          <p:cNvPr id="12" name="TextBox 11"/>
-          <p:cNvSpPr txBox="1"/>
-          <p:nvPr/>
-        </p:nvSpPr>
-        <p:spPr>
-          <a:xfrm>
-            <a:off x="6565392" y="1984248"/>
-            <a:ext cx="4663440" cy="457200"/>
-          </a:xfrm>
-          <a:prstGeom prst="rect">
-            <a:avLst/>
-          </a:prstGeom>
-          <a:noFill/>
-        </p:spPr>
-        <p:txBody>
-          <a:bodyPr wrap="square" lIns="0" rIns="0" tIns="0" bIns="0">
-            <a:spAutoFit/>
-          </a:bodyPr>
-          <a:lstStyle/>
-          <a:p>
-            <a:pPr algn="l">
-              <a:spcBef>
-                <a:spcPts val="0"/>
-              </a:spcBef>
-              <a:spcAft>
-                <a:spcPts val="0"/>
-              </a:spcAft>
-              <a:buNone/>
-            </a:pPr>
-            <a:r>
-              <a:rPr sz="1600" b="1">
+                <a:spcPts val="1000"/>
+              </a:spcAft>
+              <a:buNone/>
+            </a:pPr>
+            <a:r>
+              <a:rPr sz="3800" b="1">
                 <a:solidFill>
                   <a:srgbClr val="FFFFFF"/>
                 </a:solidFill>
                 <a:latin typeface="Segoe UI Semibold"/>
               </a:rPr>
-              <a:t>UPSELL: same API + your Azure creds</a:t>
-            </a:r>
-          </a:p>
-        </p:txBody>
-      </p:sp>
-      <p:sp>
-        <p:nvSpPr>
-          <p:cNvPr id="13" name="TextBox 12"/>
-          <p:cNvSpPr txBox="1"/>
-          <p:nvPr/>
-        </p:nvSpPr>
-        <p:spPr>
-          <a:xfrm>
-            <a:off x="6565392" y="2651760"/>
-            <a:ext cx="4663440" cy="1828800"/>
-          </a:xfrm>
-          <a:prstGeom prst="rect">
-            <a:avLst/>
-          </a:prstGeom>
-          <a:noFill/>
-        </p:spPr>
-        <p:txBody>
-          <a:bodyPr wrap="square" lIns="0" rIns="0" tIns="0" bIns="0">
-            <a:spAutoFit/>
-          </a:bodyPr>
-          <a:lstStyle/>
-          <a:p>
-            <a:pPr algn="l">
-              <a:spcBef>
-                <a:spcPts val="0"/>
-              </a:spcBef>
-              <a:spcAft>
-                <a:spcPts val="900"/>
-              </a:spcAft>
-              <a:buFont typeface="Segoe UI"/>
-              <a:buChar char="•"/>
-            </a:pPr>
-            <a:r>
-              <a:rPr sz="1500" b="0">
-                <a:solidFill>
-                  <a:srgbClr val="1F1F1F"/>
-                </a:solidFill>
-                <a:latin typeface="Segoe UI"/>
-              </a:rPr>
-              <a:t>More voices, more languages, server-side scale.</a:t>
-            </a:r>
-          </a:p>
-          <a:p>
-            <a:pPr algn="l">
-              <a:spcBef>
-                <a:spcPts val="0"/>
-              </a:spcBef>
-              <a:spcAft>
-                <a:spcPts val="900"/>
-              </a:spcAft>
-              <a:buFont typeface="Segoe UI"/>
-              <a:buChar char="•"/>
-            </a:pPr>
-            <a:r>
-              <a:rPr sz="1500" b="0">
-                <a:solidFill>
-                  <a:srgbClr val="1F1F1F"/>
-                </a:solidFill>
-                <a:latin typeface="Segoe UI"/>
-              </a:rPr>
-              <a:t>Batch, streaming, and cross-device workloads.</a:t>
-            </a:r>
-          </a:p>
-          <a:p>
-            <a:pPr algn="l">
-              <a:spcBef>
-                <a:spcPts val="0"/>
-              </a:spcBef>
-              <a:spcAft>
-                <a:spcPts val="900"/>
-              </a:spcAft>
-              <a:buFont typeface="Segoe UI"/>
-              <a:buChar char="•"/>
-            </a:pPr>
-            <a:r>
-              <a:rPr sz="1500" b="0">
-                <a:solidFill>
-                  <a:srgbClr val="1F1F1F"/>
-                </a:solidFill>
-                <a:latin typeface="Segoe UI"/>
-              </a:rPr>
-              <a:t>Same code path; credentials switch the backend.</a:t>
-            </a:r>
-          </a:p>
-        </p:txBody>
-      </p:sp>
-      <p:sp>
-        <p:nvSpPr>
-          <p:cNvPr id="14" name="Right Arrow 13"/>
-          <p:cNvSpPr/>
-          <p:nvPr/>
-        </p:nvSpPr>
-        <p:spPr>
-          <a:xfrm>
-            <a:off x="5852160" y="3063240"/>
-            <a:ext cx="502920" cy="365760"/>
-          </a:xfrm>
-          <a:prstGeom prst="rightArrow">
-            <a:avLst/>
-          </a:prstGeom>
-          <a:solidFill>
-            <a:srgbClr val="CA5F00"/>
-          </a:solidFill>
-          <a:ln>
-            <a:noFill/>
-          </a:ln>
-          <a:effectLst/>
-        </p:spPr>
-        <p:style>
-          <a:lnRef idx="1">
-            <a:schemeClr val="accent1"/>
-          </a:lnRef>
-          <a:fillRef idx="3">
-            <a:schemeClr val="accent1"/>
-          </a:fillRef>
-          <a:effectRef idx="2">
-            <a:schemeClr val="accent1"/>
-          </a:effectRef>
-          <a:fontRef idx="minor">
-            <a:schemeClr val="lt1"/>
-          </a:fontRef>
-        </p:style>
-        <p:txBody>
-          <a:bodyPr rtlCol="0" anchor="ctr"/>
-          <a:lstStyle/>
-          <a:p>
-            <a:pPr algn="ctr"/>
-          </a:p>
-        </p:txBody>
-      </p:sp>
-      <p:sp>
-        <p:nvSpPr>
-          <p:cNvPr id="15" name="Rectangle 14"/>
-          <p:cNvSpPr/>
-          <p:nvPr/>
-        </p:nvSpPr>
-        <p:spPr>
-          <a:xfrm>
-            <a:off x="658368" y="4892040"/>
-            <a:ext cx="10881360" cy="960120"/>
-          </a:xfrm>
-          <a:prstGeom prst="rect">
-            <a:avLst/>
-          </a:prstGeom>
-          <a:solidFill>
-            <a:srgbClr val="EAF1FB"/>
-          </a:solidFill>
-          <a:ln>
-            <a:noFill/>
-          </a:ln>
-          <a:effectLst/>
-        </p:spPr>
-        <p:style>
-          <a:lnRef idx="1">
-            <a:schemeClr val="accent1"/>
-          </a:lnRef>
-          <a:fillRef idx="3">
-            <a:schemeClr val="accent1"/>
-          </a:fillRef>
-          <a:effectRef idx="2">
-            <a:schemeClr val="accent1"/>
-          </a:effectRef>
-          <a:fontRef idx="minor">
-            <a:schemeClr val="lt1"/>
-          </a:fontRef>
-        </p:style>
-        <p:txBody>
-          <a:bodyPr rtlCol="0" anchor="ctr"/>
-          <a:lstStyle/>
-          <a:p>
-            <a:pPr algn="ctr"/>
-          </a:p>
-        </p:txBody>
-      </p:sp>
-      <p:sp>
-        <p:nvSpPr>
-          <p:cNvPr id="16" name="TextBox 15"/>
-          <p:cNvSpPr txBox="1"/>
-          <p:nvPr/>
-        </p:nvSpPr>
-        <p:spPr>
-          <a:xfrm>
-            <a:off x="932688" y="5074920"/>
-            <a:ext cx="10332720" cy="685800"/>
-          </a:xfrm>
-          <a:prstGeom prst="rect">
-            <a:avLst/>
-          </a:prstGeom>
-          <a:noFill/>
-        </p:spPr>
-        <p:txBody>
-          <a:bodyPr wrap="square" lIns="0" rIns="0" tIns="0" bIns="0" anchor="ctr">
-            <a:spAutoFit/>
-          </a:bodyPr>
-          <a:lstStyle/>
-          <a:p>
-            <a:pPr algn="l">
-              <a:spcBef>
-                <a:spcPts val="0"/>
-              </a:spcBef>
-              <a:spcAft>
-                <a:spcPts val="0"/>
-              </a:spcAft>
-              <a:buNone/>
-            </a:pPr>
-            <a:r>
-              <a:rPr sz="1600" b="1">
-                <a:solidFill>
-                  <a:srgbClr val="103A5E"/>
-                </a:solidFill>
-                <a:latin typeface="Segoe UI Semibold"/>
-              </a:rPr>
-              <a:t>Local is the free on-ramp; Azure is the paid upsell. Apple stops at the device, with no cloud to graduate to. Windows plus Azure plus Microsoft's own apps is a funnel no competitor can match.</a:t>
-            </a:r>
-          </a:p>
-        </p:txBody>
-      </p:sp>
-      <p:sp>
-        <p:nvSpPr>
-          <p:cNvPr id="17" name="TextBox 16"/>
-          <p:cNvSpPr txBox="1"/>
-          <p:nvPr/>
-        </p:nvSpPr>
-        <p:spPr>
-          <a:xfrm>
-            <a:off x="502920" y="6419088"/>
-            <a:ext cx="8229600" cy="320040"/>
-          </a:xfrm>
-          <a:prstGeom prst="rect">
-            <a:avLst/>
-          </a:prstGeom>
-          <a:noFill/>
-        </p:spPr>
-        <p:txBody>
-          <a:bodyPr wrap="square" lIns="0" rIns="0" tIns="0" bIns="0">
-            <a:spAutoFit/>
-          </a:bodyPr>
-          <a:lstStyle/>
-          <a:p>
-            <a:pPr algn="l">
-              <a:spcBef>
-                <a:spcPts val="0"/>
-              </a:spcBef>
-              <a:spcAft>
-                <a:spcPts val="0"/>
-              </a:spcAft>
-              <a:buNone/>
-            </a:pPr>
-            <a:r>
-              <a:rPr sz="1000" b="0">
-                <a:solidFill>
-                  <a:srgbClr val="606060"/>
-                </a:solidFill>
-                <a:latin typeface="Segoe UI"/>
-              </a:rPr>
-              <a:t>WindowsNaturalVoices  ·  on-device HD voices, offline</a:t>
-            </a:r>
-          </a:p>
-        </p:txBody>
-      </p:sp>
-      <p:sp>
-        <p:nvSpPr>
-          <p:cNvPr id="18" name="TextBox 17"/>
-          <p:cNvSpPr txBox="1"/>
-          <p:nvPr/>
-        </p:nvSpPr>
-        <p:spPr>
-          <a:xfrm>
-            <a:off x="11155680" y="6419088"/>
-            <a:ext cx="640080" cy="320040"/>
-          </a:xfrm>
-          <a:prstGeom prst="rect">
-            <a:avLst/>
-          </a:prstGeom>
-          <a:noFill/>
-        </p:spPr>
-        <p:txBody>
-          <a:bodyPr wrap="square" lIns="0" rIns="0" tIns="0" bIns="0">
-            <a:spAutoFit/>
-          </a:bodyPr>
-          <a:lstStyle/>
-          <a:p>
-            <a:pPr algn="r">
-              <a:spcBef>
-                <a:spcPts val="0"/>
-              </a:spcBef>
-              <a:spcAft>
-                <a:spcPts val="0"/>
-              </a:spcAft>
-              <a:buNone/>
-            </a:pPr>
-            <a:r>
-              <a:rPr sz="1000" b="0">
-                <a:solidFill>
-                  <a:srgbClr val="606060"/>
-                </a:solidFill>
-                <a:latin typeface="Segoe UI"/>
-              </a:rPr>
-              <a:t>14</a:t>
+              <a:t>Make the POC real: remove the hack, ship the API</a:t>
+            </a:r>
+          </a:p>
+          <a:p>
+            <a:pPr algn="l">
+              <a:spcBef>
+                <a:spcPts val="0"/>
+              </a:spcBef>
+              <a:spcAft>
+                <a:spcPts val="0"/>
+              </a:spcAft>
+              <a:buNone/>
+            </a:pPr>
+            <a:r>
+              <a:rPr sz="1800" b="0">
+                <a:solidFill>
+                  <a:srgbClr val="CFE0F3"/>
+                </a:solidFill>
+                <a:latin typeface="Segoe UI Light"/>
+              </a:rPr>
+              <a:t>One API surface. Local-first and free by default, and the same code scales to Azure with your creds.</a:t>
             </a:r>
           </a:p>
         </p:txBody>
@@ -6997,7 +8155,501 @@
             <a:avLst/>
           </a:prstGeom>
           <a:solidFill>
-            <a:srgbClr val="103A5E"/>
+            <a:srgbClr val="FFFFFF"/>
+          </a:solidFill>
+          <a:ln>
+            <a:noFill/>
+          </a:ln>
+          <a:effectLst/>
+        </p:spPr>
+        <p:style>
+          <a:lnRef idx="1">
+            <a:schemeClr val="accent1"/>
+          </a:lnRef>
+          <a:fillRef idx="3">
+            <a:schemeClr val="accent1"/>
+          </a:fillRef>
+          <a:effectRef idx="2">
+            <a:schemeClr val="accent1"/>
+          </a:effectRef>
+          <a:fontRef idx="minor">
+            <a:schemeClr val="lt1"/>
+          </a:fontRef>
+        </p:style>
+        <p:txBody>
+          <a:bodyPr rtlCol="0" anchor="ctr"/>
+          <a:lstStyle/>
+          <a:p>
+            <a:pPr algn="ctr"/>
+          </a:p>
+        </p:txBody>
+      </p:sp>
+      <p:sp>
+        <p:nvSpPr>
+          <p:cNvPr id="3" name="Rectangle 2"/>
+          <p:cNvSpPr/>
+          <p:nvPr/>
+        </p:nvSpPr>
+        <p:spPr>
+          <a:xfrm>
+            <a:off x="0" y="0"/>
+            <a:ext cx="12191695" cy="146304"/>
+          </a:xfrm>
+          <a:prstGeom prst="rect">
+            <a:avLst/>
+          </a:prstGeom>
+          <a:solidFill>
+            <a:srgbClr val="CA5F00"/>
+          </a:solidFill>
+          <a:ln>
+            <a:noFill/>
+          </a:ln>
+          <a:effectLst/>
+        </p:spPr>
+        <p:style>
+          <a:lnRef idx="1">
+            <a:schemeClr val="accent1"/>
+          </a:lnRef>
+          <a:fillRef idx="3">
+            <a:schemeClr val="accent1"/>
+          </a:fillRef>
+          <a:effectRef idx="2">
+            <a:schemeClr val="accent1"/>
+          </a:effectRef>
+          <a:fontRef idx="minor">
+            <a:schemeClr val="lt1"/>
+          </a:fontRef>
+        </p:style>
+        <p:txBody>
+          <a:bodyPr rtlCol="0" anchor="ctr"/>
+          <a:lstStyle/>
+          <a:p>
+            <a:pPr algn="ctr"/>
+          </a:p>
+        </p:txBody>
+      </p:sp>
+      <p:sp>
+        <p:nvSpPr>
+          <p:cNvPr id="4" name="TextBox 3"/>
+          <p:cNvSpPr txBox="1"/>
+          <p:nvPr/>
+        </p:nvSpPr>
+        <p:spPr>
+          <a:xfrm>
+            <a:off x="502920" y="411480"/>
+            <a:ext cx="11155680" cy="365760"/>
+          </a:xfrm>
+          <a:prstGeom prst="rect">
+            <a:avLst/>
+          </a:prstGeom>
+          <a:noFill/>
+        </p:spPr>
+        <p:txBody>
+          <a:bodyPr wrap="square" lIns="0" rIns="0" tIns="0" bIns="0">
+            <a:spAutoFit/>
+          </a:bodyPr>
+          <a:lstStyle/>
+          <a:p>
+            <a:pPr algn="l">
+              <a:spcBef>
+                <a:spcPts val="0"/>
+              </a:spcBef>
+              <a:spcAft>
+                <a:spcPts val="0"/>
+              </a:spcAft>
+              <a:buNone/>
+            </a:pPr>
+            <a:r>
+              <a:rPr sz="1300" b="1">
+                <a:solidFill>
+                  <a:srgbClr val="CA5F00"/>
+                </a:solidFill>
+                <a:latin typeface="Segoe UI Semibold"/>
+              </a:rPr>
+              <a:t>HOW · THE FRICTION TODAY</a:t>
+            </a:r>
+          </a:p>
+        </p:txBody>
+      </p:sp>
+      <p:sp>
+        <p:nvSpPr>
+          <p:cNvPr id="5" name="TextBox 4"/>
+          <p:cNvSpPr txBox="1"/>
+          <p:nvPr/>
+        </p:nvSpPr>
+        <p:spPr>
+          <a:xfrm>
+            <a:off x="502920" y="777240"/>
+            <a:ext cx="11155680" cy="914400"/>
+          </a:xfrm>
+          <a:prstGeom prst="rect">
+            <a:avLst/>
+          </a:prstGeom>
+          <a:noFill/>
+        </p:spPr>
+        <p:txBody>
+          <a:bodyPr wrap="square" lIns="0" rIns="0" tIns="0" bIns="0">
+            <a:spAutoFit/>
+          </a:bodyPr>
+          <a:lstStyle/>
+          <a:p>
+            <a:pPr algn="l">
+              <a:spcBef>
+                <a:spcPts val="0"/>
+              </a:spcBef>
+              <a:spcAft>
+                <a:spcPts val="0"/>
+              </a:spcAft>
+              <a:buNone/>
+            </a:pPr>
+            <a:r>
+              <a:rPr sz="3000" b="1">
+                <a:solidFill>
+                  <a:srgbClr val="1F1F1F"/>
+                </a:solidFill>
+                <a:latin typeface="Segoe UI Semibold"/>
+              </a:rPr>
+              <a:t>It works, but only as a hack</a:t>
+            </a:r>
+          </a:p>
+        </p:txBody>
+      </p:sp>
+      <p:sp>
+        <p:nvSpPr>
+          <p:cNvPr id="6" name="TextBox 5"/>
+          <p:cNvSpPr txBox="1"/>
+          <p:nvPr/>
+        </p:nvSpPr>
+        <p:spPr>
+          <a:xfrm>
+            <a:off x="640080" y="1828800"/>
+            <a:ext cx="10881360" cy="1280160"/>
+          </a:xfrm>
+          <a:prstGeom prst="rect">
+            <a:avLst/>
+          </a:prstGeom>
+          <a:noFill/>
+        </p:spPr>
+        <p:txBody>
+          <a:bodyPr wrap="square" lIns="0" rIns="0" tIns="0" bIns="0">
+            <a:spAutoFit/>
+          </a:bodyPr>
+          <a:lstStyle/>
+          <a:p>
+            <a:pPr algn="l">
+              <a:spcBef>
+                <a:spcPts val="0"/>
+              </a:spcBef>
+              <a:spcAft>
+                <a:spcPts val="1000"/>
+              </a:spcAft>
+              <a:buNone/>
+            </a:pPr>
+            <a:r>
+              <a:rPr sz="1700" b="0">
+                <a:solidFill>
+                  <a:srgbClr val="1F1F1F"/>
+                </a:solidFill>
+                <a:latin typeface="Segoe UI"/>
+              </a:rPr>
+              <a:t>To reach the on-device HD voice and Live Captions runtimes with no public API, this reference implementation has to:</a:t>
+            </a:r>
+          </a:p>
+        </p:txBody>
+      </p:sp>
+      <p:sp>
+        <p:nvSpPr>
+          <p:cNvPr id="7" name="TextBox 6"/>
+          <p:cNvSpPr txBox="1"/>
+          <p:nvPr/>
+        </p:nvSpPr>
+        <p:spPr>
+          <a:xfrm>
+            <a:off x="914400" y="2880360"/>
+            <a:ext cx="10424160" cy="1737360"/>
+          </a:xfrm>
+          <a:prstGeom prst="rect">
+            <a:avLst/>
+          </a:prstGeom>
+          <a:noFill/>
+        </p:spPr>
+        <p:txBody>
+          <a:bodyPr wrap="square" lIns="0" rIns="0" tIns="0" bIns="0">
+            <a:spAutoFit/>
+          </a:bodyPr>
+          <a:lstStyle/>
+          <a:p>
+            <a:pPr algn="l">
+              <a:spcBef>
+                <a:spcPts val="0"/>
+              </a:spcBef>
+              <a:spcAft>
+                <a:spcPts val="1000"/>
+              </a:spcAft>
+              <a:buFont typeface="Segoe UI"/>
+              <a:buChar char="•"/>
+            </a:pPr>
+            <a:r>
+              <a:rPr sz="1700" b="0">
+                <a:solidFill>
+                  <a:srgbClr val="1F1F1F"/>
+                </a:solidFill>
+                <a:latin typeface="Segoe UI"/>
+              </a:rPr>
+              <a:t>Pass an undocumented Embedded Speech license string to unlock synthesis.</a:t>
+            </a:r>
+          </a:p>
+          <a:p>
+            <a:pPr algn="l">
+              <a:spcBef>
+                <a:spcPts val="0"/>
+              </a:spcBef>
+              <a:spcAft>
+                <a:spcPts val="1000"/>
+              </a:spcAft>
+              <a:buFont typeface="Segoe UI"/>
+              <a:buChar char="•"/>
+            </a:pPr>
+            <a:r>
+              <a:rPr sz="1700" b="0">
+                <a:solidFill>
+                  <a:srgbClr val="1F1F1F"/>
+                </a:solidFill>
+                <a:latin typeface="Segoe UI"/>
+              </a:rPr>
+              <a:t>Load gated extension DLLs out of a first-party SystemApps folder.</a:t>
+            </a:r>
+          </a:p>
+          <a:p>
+            <a:pPr algn="l">
+              <a:spcBef>
+                <a:spcPts val="0"/>
+              </a:spcBef>
+              <a:spcAft>
+                <a:spcPts val="1000"/>
+              </a:spcAft>
+              <a:buFont typeface="Segoe UI"/>
+              <a:buChar char="•"/>
+            </a:pPr>
+            <a:r>
+              <a:rPr sz="1700" b="0">
+                <a:solidFill>
+                  <a:srgbClr val="1F1F1F"/>
+                </a:solidFill>
+                <a:latin typeface="Segoe UI"/>
+              </a:rPr>
+              <a:t>Resolve native dependencies by walking the package graph by hand.</a:t>
+            </a:r>
+          </a:p>
+        </p:txBody>
+      </p:sp>
+      <p:sp>
+        <p:nvSpPr>
+          <p:cNvPr id="8" name="Rectangle 7"/>
+          <p:cNvSpPr/>
+          <p:nvPr/>
+        </p:nvSpPr>
+        <p:spPr>
+          <a:xfrm>
+            <a:off x="640080" y="4892040"/>
+            <a:ext cx="10881360" cy="960120"/>
+          </a:xfrm>
+          <a:prstGeom prst="rect">
+            <a:avLst/>
+          </a:prstGeom>
+          <a:solidFill>
+            <a:srgbClr val="FBF0E6"/>
+          </a:solidFill>
+          <a:ln>
+            <a:noFill/>
+          </a:ln>
+          <a:effectLst/>
+        </p:spPr>
+        <p:style>
+          <a:lnRef idx="1">
+            <a:schemeClr val="accent1"/>
+          </a:lnRef>
+          <a:fillRef idx="3">
+            <a:schemeClr val="accent1"/>
+          </a:fillRef>
+          <a:effectRef idx="2">
+            <a:schemeClr val="accent1"/>
+          </a:effectRef>
+          <a:fontRef idx="minor">
+            <a:schemeClr val="lt1"/>
+          </a:fontRef>
+        </p:style>
+        <p:txBody>
+          <a:bodyPr rtlCol="0" anchor="ctr"/>
+          <a:lstStyle/>
+          <a:p>
+            <a:pPr algn="ctr"/>
+          </a:p>
+        </p:txBody>
+      </p:sp>
+      <p:sp>
+        <p:nvSpPr>
+          <p:cNvPr id="9" name="TextBox 8"/>
+          <p:cNvSpPr txBox="1"/>
+          <p:nvPr/>
+        </p:nvSpPr>
+        <p:spPr>
+          <a:xfrm>
+            <a:off x="914400" y="5074920"/>
+            <a:ext cx="10332720" cy="685800"/>
+          </a:xfrm>
+          <a:prstGeom prst="rect">
+            <a:avLst/>
+          </a:prstGeom>
+          <a:noFill/>
+        </p:spPr>
+        <p:txBody>
+          <a:bodyPr wrap="square" lIns="0" rIns="0" tIns="0" bIns="0" anchor="ctr">
+            <a:spAutoFit/>
+          </a:bodyPr>
+          <a:lstStyle/>
+          <a:p>
+            <a:pPr algn="l">
+              <a:spcBef>
+                <a:spcPts val="0"/>
+              </a:spcBef>
+              <a:spcAft>
+                <a:spcPts val="0"/>
+              </a:spcAft>
+              <a:buNone/>
+            </a:pPr>
+            <a:r>
+              <a:rPr sz="1600" b="1">
+                <a:solidFill>
+                  <a:srgbClr val="CA5F00"/>
+                </a:solidFill>
+                <a:latin typeface="Segoe UI Semibold"/>
+              </a:rPr>
+              <a:t>Unsupported and fragile, exactly the friction that stops real products from shipping on the capability. That's what the API removes.</a:t>
+            </a:r>
+          </a:p>
+        </p:txBody>
+      </p:sp>
+      <p:sp>
+        <p:nvSpPr>
+          <p:cNvPr id="10" name="TextBox 9"/>
+          <p:cNvSpPr txBox="1"/>
+          <p:nvPr/>
+        </p:nvSpPr>
+        <p:spPr>
+          <a:xfrm>
+            <a:off x="502920" y="6419088"/>
+            <a:ext cx="8229600" cy="320040"/>
+          </a:xfrm>
+          <a:prstGeom prst="rect">
+            <a:avLst/>
+          </a:prstGeom>
+          <a:noFill/>
+        </p:spPr>
+        <p:txBody>
+          <a:bodyPr wrap="square" lIns="0" rIns="0" tIns="0" bIns="0">
+            <a:spAutoFit/>
+          </a:bodyPr>
+          <a:lstStyle/>
+          <a:p>
+            <a:pPr algn="l">
+              <a:spcBef>
+                <a:spcPts val="0"/>
+              </a:spcBef>
+              <a:spcAft>
+                <a:spcPts val="0"/>
+              </a:spcAft>
+              <a:buNone/>
+            </a:pPr>
+            <a:r>
+              <a:rPr sz="1000" b="0">
+                <a:solidFill>
+                  <a:srgbClr val="606060"/>
+                </a:solidFill>
+                <a:latin typeface="Segoe UI"/>
+              </a:rPr>
+              <a:t>WindowsNaturalVoices  ·  on-device speech, offline</a:t>
+            </a:r>
+          </a:p>
+        </p:txBody>
+      </p:sp>
+      <p:sp>
+        <p:nvSpPr>
+          <p:cNvPr id="11" name="TextBox 10"/>
+          <p:cNvSpPr txBox="1"/>
+          <p:nvPr/>
+        </p:nvSpPr>
+        <p:spPr>
+          <a:xfrm>
+            <a:off x="11155680" y="6419088"/>
+            <a:ext cx="640080" cy="320040"/>
+          </a:xfrm>
+          <a:prstGeom prst="rect">
+            <a:avLst/>
+          </a:prstGeom>
+          <a:noFill/>
+        </p:spPr>
+        <p:txBody>
+          <a:bodyPr wrap="square" lIns="0" rIns="0" tIns="0" bIns="0">
+            <a:spAutoFit/>
+          </a:bodyPr>
+          <a:lstStyle/>
+          <a:p>
+            <a:pPr algn="r">
+              <a:spcBef>
+                <a:spcPts val="0"/>
+              </a:spcBef>
+              <a:spcAft>
+                <a:spcPts val="0"/>
+              </a:spcAft>
+              <a:buNone/>
+            </a:pPr>
+            <a:r>
+              <a:rPr sz="1000" b="0">
+                <a:solidFill>
+                  <a:srgbClr val="606060"/>
+                </a:solidFill>
+                <a:latin typeface="Segoe UI"/>
+              </a:rPr>
+              <a:t>15</a:t>
+            </a:r>
+          </a:p>
+        </p:txBody>
+      </p:sp>
+    </p:spTree>
+  </p:cSld>
+  <p:clrMapOvr>
+    <a:masterClrMapping/>
+  </p:clrMapOvr>
+</p:sld>
+</file>
+
+<file path=ppt/slides/slide16.xml><?xml version="1.0" encoding="utf-8"?>
+<p:sld xmlns:a="http://schemas.openxmlformats.org/drawingml/2006/main" xmlns:p="http://schemas.openxmlformats.org/presentationml/2006/main" xmlns:r="http://schemas.openxmlformats.org/officeDocument/2006/relationships">
+  <p:cSld>
+    <p:spTree>
+      <p:nvGrpSpPr>
+        <p:cNvPr id="1" name=""/>
+        <p:cNvGrpSpPr/>
+        <p:nvPr/>
+      </p:nvGrpSpPr>
+      <p:grpSpPr/>
+      <p:sp>
+        <p:nvSpPr>
+          <p:cNvPr id="2" name="Rectangle 1"/>
+          <p:cNvSpPr/>
+          <p:nvPr/>
+        </p:nvSpPr>
+        <p:spPr>
+          <a:xfrm>
+            <a:off x="0" y="0"/>
+            <a:ext cx="12191695" cy="6858000"/>
+          </a:xfrm>
+          <a:prstGeom prst="rect">
+            <a:avLst/>
+          </a:prstGeom>
+          <a:solidFill>
+            <a:srgbClr val="F3F6FB"/>
           </a:solidFill>
           <a:ln>
             <a:noFill/>
@@ -7078,8 +8730,8 @@
         </p:nvSpPr>
         <p:spPr>
           <a:xfrm>
-            <a:off x="640080" y="594360"/>
-            <a:ext cx="10972800" cy="1097280"/>
+            <a:off x="502920" y="411480"/>
+            <a:ext cx="11155680" cy="365760"/>
           </a:xfrm>
           <a:prstGeom prst="rect">
             <a:avLst/>
@@ -7097,38 +8749,18 @@
                 <a:spcPts val="0"/>
               </a:spcBef>
               <a:spcAft>
-                <a:spcPts val="600"/>
-              </a:spcAft>
-              <a:buNone/>
-            </a:pPr>
-            <a:r>
-              <a:rPr sz="1400" b="1">
-                <a:solidFill>
-                  <a:srgbClr val="8FC4F0"/>
+                <a:spcPts val="0"/>
+              </a:spcAft>
+              <a:buNone/>
+            </a:pPr>
+            <a:r>
+              <a:rPr sz="1300" b="1">
+                <a:solidFill>
+                  <a:srgbClr val="0078D4"/>
                 </a:solidFill>
                 <a:latin typeface="Segoe UI Semibold"/>
               </a:rPr>
-              <a:t>THE ASK TO MICROSOFT</a:t>
-            </a:r>
-          </a:p>
-          <a:p>
-            <a:pPr algn="l">
-              <a:spcBef>
-                <a:spcPts val="0"/>
-              </a:spcBef>
-              <a:spcAft>
-                <a:spcPts val="0"/>
-              </a:spcAft>
-              <a:buNone/>
-            </a:pPr>
-            <a:r>
-              <a:rPr sz="3200" b="1">
-                <a:solidFill>
-                  <a:srgbClr val="FFFFFF"/>
-                </a:solidFill>
-                <a:latin typeface="Segoe UI Semibold"/>
-              </a:rPr>
-              <a:t>Ship this as a first-class Windows API</a:t>
+              <a:t>HOW · THE DESIGN</a:t>
             </a:r>
           </a:p>
         </p:txBody>
@@ -7141,8 +8773,8 @@
         </p:nvSpPr>
         <p:spPr>
           <a:xfrm>
-            <a:off x="640080" y="1828800"/>
-            <a:ext cx="10881360" cy="1005840"/>
+            <a:off x="502920" y="777240"/>
+            <a:ext cx="11155680" cy="914400"/>
           </a:xfrm>
           <a:prstGeom prst="rect">
             <a:avLst/>
@@ -7165,27 +8797,117 @@
               <a:buNone/>
             </a:pPr>
             <a:r>
-              <a:rPr sz="1600" b="0">
-                <a:solidFill>
-                  <a:srgbClr val="CFE0F3"/>
-                </a:solidFill>
-                <a:latin typeface="Segoe UI"/>
-              </a:rPr>
-              <a:t>This repo is a working reference implementation of what it should look like. Take the hack out; make it supported:</a:t>
-            </a:r>
-          </a:p>
-        </p:txBody>
-      </p:sp>
-      <p:sp>
-        <p:nvSpPr>
-          <p:cNvPr id="6" name="TextBox 5"/>
+              <a:rPr sz="3000" b="1">
+                <a:solidFill>
+                  <a:srgbClr val="1F1F1F"/>
+                </a:solidFill>
+                <a:latin typeface="Segoe UI Semibold"/>
+              </a:rPr>
+              <a:t>One API. Local by default. Cloud when you want it.</a:t>
+            </a:r>
+          </a:p>
+        </p:txBody>
+      </p:sp>
+      <p:sp>
+        <p:nvSpPr>
+          <p:cNvPr id="6" name="Rectangle 5"/>
+          <p:cNvSpPr/>
+          <p:nvPr/>
+        </p:nvSpPr>
+        <p:spPr>
+          <a:xfrm>
+            <a:off x="658368" y="1874519"/>
+            <a:ext cx="5257800" cy="2743200"/>
+          </a:xfrm>
+          <a:prstGeom prst="rect">
+            <a:avLst/>
+          </a:prstGeom>
+          <a:solidFill>
+            <a:srgbClr val="FFFFFF"/>
+          </a:solidFill>
+          <a:ln w="12700">
+            <a:solidFill>
+              <a:srgbClr val="D9E4F0"/>
+            </a:solidFill>
+          </a:ln>
+          <a:effectLst/>
+        </p:spPr>
+        <p:style>
+          <a:lnRef idx="1">
+            <a:schemeClr val="accent1"/>
+          </a:lnRef>
+          <a:fillRef idx="3">
+            <a:schemeClr val="accent1"/>
+          </a:fillRef>
+          <a:effectRef idx="2">
+            <a:schemeClr val="accent1"/>
+          </a:effectRef>
+          <a:fontRef idx="minor">
+            <a:schemeClr val="lt1"/>
+          </a:fontRef>
+        </p:style>
+        <p:txBody>
+          <a:bodyPr rtlCol="0" anchor="ctr"/>
+          <a:lstStyle/>
+          <a:p>
+            <a:pPr algn="ctr"/>
+          </a:p>
+        </p:txBody>
+      </p:sp>
+      <p:sp>
+        <p:nvSpPr>
+          <p:cNvPr id="7" name="Rectangle 6"/>
+          <p:cNvSpPr/>
+          <p:nvPr/>
+        </p:nvSpPr>
+        <p:spPr>
+          <a:xfrm>
+            <a:off x="658368" y="1874519"/>
+            <a:ext cx="5257800" cy="566928"/>
+          </a:xfrm>
+          <a:prstGeom prst="rect">
+            <a:avLst/>
+          </a:prstGeom>
+          <a:solidFill>
+            <a:srgbClr val="00998A"/>
+          </a:solidFill>
+          <a:ln>
+            <a:noFill/>
+          </a:ln>
+          <a:effectLst/>
+        </p:spPr>
+        <p:style>
+          <a:lnRef idx="1">
+            <a:schemeClr val="accent1"/>
+          </a:lnRef>
+          <a:fillRef idx="3">
+            <a:schemeClr val="accent1"/>
+          </a:fillRef>
+          <a:effectRef idx="2">
+            <a:schemeClr val="accent1"/>
+          </a:effectRef>
+          <a:fontRef idx="minor">
+            <a:schemeClr val="lt1"/>
+          </a:fontRef>
+        </p:style>
+        <p:txBody>
+          <a:bodyPr rtlCol="0" anchor="ctr"/>
+          <a:lstStyle/>
+          <a:p>
+            <a:pPr algn="ctr"/>
+          </a:p>
+        </p:txBody>
+      </p:sp>
+      <p:sp>
+        <p:nvSpPr>
+          <p:cNvPr id="8" name="TextBox 7"/>
           <p:cNvSpPr txBox="1"/>
           <p:nvPr/>
         </p:nvSpPr>
         <p:spPr>
           <a:xfrm>
-            <a:off x="914400" y="2880360"/>
-            <a:ext cx="10424160" cy="2011680"/>
+            <a:off x="950976" y="1984248"/>
+            <a:ext cx="4663440" cy="457200"/>
           </a:xfrm>
           <a:prstGeom prst="rect">
             <a:avLst/>
@@ -7203,76 +8925,874 @@
                 <a:spcPts val="0"/>
               </a:spcBef>
               <a:spcAft>
-                <a:spcPts val="1000"/>
+                <a:spcPts val="0"/>
+              </a:spcAft>
+              <a:buNone/>
+            </a:pPr>
+            <a:r>
+              <a:rPr sz="1600" b="1">
+                <a:solidFill>
+                  <a:srgbClr val="FFFFFF"/>
+                </a:solidFill>
+                <a:latin typeface="Segoe UI Semibold"/>
+              </a:rPr>
+              <a:t>DEFAULT: on-device</a:t>
+            </a:r>
+          </a:p>
+        </p:txBody>
+      </p:sp>
+      <p:sp>
+        <p:nvSpPr>
+          <p:cNvPr id="9" name="TextBox 8"/>
+          <p:cNvSpPr txBox="1"/>
+          <p:nvPr/>
+        </p:nvSpPr>
+        <p:spPr>
+          <a:xfrm>
+            <a:off x="950976" y="2651760"/>
+            <a:ext cx="4663440" cy="1828800"/>
+          </a:xfrm>
+          <a:prstGeom prst="rect">
+            <a:avLst/>
+          </a:prstGeom>
+          <a:noFill/>
+        </p:spPr>
+        <p:txBody>
+          <a:bodyPr wrap="square" lIns="0" rIns="0" tIns="0" bIns="0">
+            <a:spAutoFit/>
+          </a:bodyPr>
+          <a:lstStyle/>
+          <a:p>
+            <a:pPr algn="l">
+              <a:spcBef>
+                <a:spcPts val="0"/>
+              </a:spcBef>
+              <a:spcAft>
+                <a:spcPts val="900"/>
               </a:spcAft>
               <a:buFont typeface="Segoe UI"/>
               <a:buChar char="•"/>
             </a:pPr>
             <a:r>
-              <a:rPr sz="1800" b="0">
-                <a:solidFill>
-                  <a:srgbClr val="FFFFFF"/>
+              <a:rPr sz="1500" b="0">
+                <a:solidFill>
+                  <a:srgbClr val="1F1F1F"/>
                 </a:solidFill>
                 <a:latin typeface="Segoe UI"/>
               </a:rPr>
-              <a:t>Enumerate installed Natural voices (locale, gender, package).</a:t>
-            </a:r>
-          </a:p>
-          <a:p>
-            <a:pPr algn="l">
-              <a:spcBef>
-                <a:spcPts val="0"/>
-              </a:spcBef>
-              <a:spcAft>
-                <a:spcPts val="1000"/>
+              <a:t>Offline, private, free, instant.</a:t>
+            </a:r>
+          </a:p>
+          <a:p>
+            <a:pPr algn="l">
+              <a:spcBef>
+                <a:spcPts val="0"/>
+              </a:spcBef>
+              <a:spcAft>
+                <a:spcPts val="900"/>
               </a:spcAft>
               <a:buFont typeface="Segoe UI"/>
               <a:buChar char="•"/>
             </a:pPr>
             <a:r>
-              <a:rPr sz="1800" b="0">
-                <a:solidFill>
-                  <a:srgbClr val="FFFFFF"/>
+              <a:rPr sz="1500" b="0">
+                <a:solidFill>
+                  <a:srgbClr val="1F1F1F"/>
                 </a:solidFill>
                 <a:latin typeface="Segoe UI"/>
               </a:rPr>
-              <a:t>Load a voice and synthesize offline through the on-device HD runtime.</a:t>
-            </a:r>
-          </a:p>
-          <a:p>
-            <a:pPr algn="l">
-              <a:spcBef>
-                <a:spcPts val="0"/>
-              </a:spcBef>
-              <a:spcAft>
-                <a:spcPts val="1000"/>
+              <a:t>Runs on the installed Natural HD voice.</a:t>
+            </a:r>
+          </a:p>
+          <a:p>
+            <a:pPr algn="l">
+              <a:spcBef>
+                <a:spcPts val="0"/>
+              </a:spcBef>
+              <a:spcAft>
+                <a:spcPts val="900"/>
               </a:spcAft>
               <a:buFont typeface="Segoe UI"/>
               <a:buChar char="•"/>
             </a:pPr>
             <a:r>
-              <a:rPr sz="1800" b="0">
+              <a:rPr sz="1500" b="0">
+                <a:solidFill>
+                  <a:srgbClr val="1F1F1F"/>
+                </a:solidFill>
+                <a:latin typeface="Segoe UI"/>
+              </a:rPr>
+              <a:t>No key, no bill, nothing leaves the device.</a:t>
+            </a:r>
+          </a:p>
+        </p:txBody>
+      </p:sp>
+      <p:sp>
+        <p:nvSpPr>
+          <p:cNvPr id="10" name="Rectangle 9"/>
+          <p:cNvSpPr/>
+          <p:nvPr/>
+        </p:nvSpPr>
+        <p:spPr>
+          <a:xfrm>
+            <a:off x="6272784" y="1874519"/>
+            <a:ext cx="5257800" cy="2743200"/>
+          </a:xfrm>
+          <a:prstGeom prst="rect">
+            <a:avLst/>
+          </a:prstGeom>
+          <a:solidFill>
+            <a:srgbClr val="FFFFFF"/>
+          </a:solidFill>
+          <a:ln w="12700">
+            <a:solidFill>
+              <a:srgbClr val="D9E4F0"/>
+            </a:solidFill>
+          </a:ln>
+          <a:effectLst/>
+        </p:spPr>
+        <p:style>
+          <a:lnRef idx="1">
+            <a:schemeClr val="accent1"/>
+          </a:lnRef>
+          <a:fillRef idx="3">
+            <a:schemeClr val="accent1"/>
+          </a:fillRef>
+          <a:effectRef idx="2">
+            <a:schemeClr val="accent1"/>
+          </a:effectRef>
+          <a:fontRef idx="minor">
+            <a:schemeClr val="lt1"/>
+          </a:fontRef>
+        </p:style>
+        <p:txBody>
+          <a:bodyPr rtlCol="0" anchor="ctr"/>
+          <a:lstStyle/>
+          <a:p>
+            <a:pPr algn="ctr"/>
+          </a:p>
+        </p:txBody>
+      </p:sp>
+      <p:sp>
+        <p:nvSpPr>
+          <p:cNvPr id="11" name="Rectangle 10"/>
+          <p:cNvSpPr/>
+          <p:nvPr/>
+        </p:nvSpPr>
+        <p:spPr>
+          <a:xfrm>
+            <a:off x="6272784" y="1874519"/>
+            <a:ext cx="5257800" cy="566928"/>
+          </a:xfrm>
+          <a:prstGeom prst="rect">
+            <a:avLst/>
+          </a:prstGeom>
+          <a:solidFill>
+            <a:srgbClr val="0078D4"/>
+          </a:solidFill>
+          <a:ln>
+            <a:noFill/>
+          </a:ln>
+          <a:effectLst/>
+        </p:spPr>
+        <p:style>
+          <a:lnRef idx="1">
+            <a:schemeClr val="accent1"/>
+          </a:lnRef>
+          <a:fillRef idx="3">
+            <a:schemeClr val="accent1"/>
+          </a:fillRef>
+          <a:effectRef idx="2">
+            <a:schemeClr val="accent1"/>
+          </a:effectRef>
+          <a:fontRef idx="minor">
+            <a:schemeClr val="lt1"/>
+          </a:fontRef>
+        </p:style>
+        <p:txBody>
+          <a:bodyPr rtlCol="0" anchor="ctr"/>
+          <a:lstStyle/>
+          <a:p>
+            <a:pPr algn="ctr"/>
+          </a:p>
+        </p:txBody>
+      </p:sp>
+      <p:sp>
+        <p:nvSpPr>
+          <p:cNvPr id="12" name="TextBox 11"/>
+          <p:cNvSpPr txBox="1"/>
+          <p:nvPr/>
+        </p:nvSpPr>
+        <p:spPr>
+          <a:xfrm>
+            <a:off x="6565392" y="1984248"/>
+            <a:ext cx="4663440" cy="457200"/>
+          </a:xfrm>
+          <a:prstGeom prst="rect">
+            <a:avLst/>
+          </a:prstGeom>
+          <a:noFill/>
+        </p:spPr>
+        <p:txBody>
+          <a:bodyPr wrap="square" lIns="0" rIns="0" tIns="0" bIns="0">
+            <a:spAutoFit/>
+          </a:bodyPr>
+          <a:lstStyle/>
+          <a:p>
+            <a:pPr algn="l">
+              <a:spcBef>
+                <a:spcPts val="0"/>
+              </a:spcBef>
+              <a:spcAft>
+                <a:spcPts val="0"/>
+              </a:spcAft>
+              <a:buNone/>
+            </a:pPr>
+            <a:r>
+              <a:rPr sz="1600" b="1">
                 <a:solidFill>
                   <a:srgbClr val="FFFFFF"/>
                 </a:solidFill>
-                <a:latin typeface="Segoe UI"/>
-              </a:rPr>
-              <a:t>Stream synthesis live to the speaker with word-boundary events.</a:t>
-            </a:r>
-          </a:p>
-          <a:p>
-            <a:pPr algn="l">
-              <a:spcBef>
-                <a:spcPts val="0"/>
-              </a:spcBef>
-              <a:spcAft>
-                <a:spcPts val="1000"/>
+                <a:latin typeface="Segoe UI Semibold"/>
+              </a:rPr>
+              <a:t>UPSELL: same API + your Azure creds</a:t>
+            </a:r>
+          </a:p>
+        </p:txBody>
+      </p:sp>
+      <p:sp>
+        <p:nvSpPr>
+          <p:cNvPr id="13" name="TextBox 12"/>
+          <p:cNvSpPr txBox="1"/>
+          <p:nvPr/>
+        </p:nvSpPr>
+        <p:spPr>
+          <a:xfrm>
+            <a:off x="6565392" y="2651760"/>
+            <a:ext cx="4663440" cy="1828800"/>
+          </a:xfrm>
+          <a:prstGeom prst="rect">
+            <a:avLst/>
+          </a:prstGeom>
+          <a:noFill/>
+        </p:spPr>
+        <p:txBody>
+          <a:bodyPr wrap="square" lIns="0" rIns="0" tIns="0" bIns="0">
+            <a:spAutoFit/>
+          </a:bodyPr>
+          <a:lstStyle/>
+          <a:p>
+            <a:pPr algn="l">
+              <a:spcBef>
+                <a:spcPts val="0"/>
+              </a:spcBef>
+              <a:spcAft>
+                <a:spcPts val="900"/>
               </a:spcAft>
               <a:buFont typeface="Segoe UI"/>
               <a:buChar char="•"/>
             </a:pPr>
             <a:r>
-              <a:rPr sz="1800" b="0">
+              <a:rPr sz="1500" b="0">
+                <a:solidFill>
+                  <a:srgbClr val="1F1F1F"/>
+                </a:solidFill>
+                <a:latin typeface="Segoe UI"/>
+              </a:rPr>
+              <a:t>More voices, more languages, server-side scale.</a:t>
+            </a:r>
+          </a:p>
+          <a:p>
+            <a:pPr algn="l">
+              <a:spcBef>
+                <a:spcPts val="0"/>
+              </a:spcBef>
+              <a:spcAft>
+                <a:spcPts val="900"/>
+              </a:spcAft>
+              <a:buFont typeface="Segoe UI"/>
+              <a:buChar char="•"/>
+            </a:pPr>
+            <a:r>
+              <a:rPr sz="1500" b="0">
+                <a:solidFill>
+                  <a:srgbClr val="1F1F1F"/>
+                </a:solidFill>
+                <a:latin typeface="Segoe UI"/>
+              </a:rPr>
+              <a:t>Batch, streaming, and cross-device workloads.</a:t>
+            </a:r>
+          </a:p>
+          <a:p>
+            <a:pPr algn="l">
+              <a:spcBef>
+                <a:spcPts val="0"/>
+              </a:spcBef>
+              <a:spcAft>
+                <a:spcPts val="900"/>
+              </a:spcAft>
+              <a:buFont typeface="Segoe UI"/>
+              <a:buChar char="•"/>
+            </a:pPr>
+            <a:r>
+              <a:rPr sz="1500" b="0">
+                <a:solidFill>
+                  <a:srgbClr val="1F1F1F"/>
+                </a:solidFill>
+                <a:latin typeface="Segoe UI"/>
+              </a:rPr>
+              <a:t>Same code path; credentials switch the backend.</a:t>
+            </a:r>
+          </a:p>
+        </p:txBody>
+      </p:sp>
+      <p:sp>
+        <p:nvSpPr>
+          <p:cNvPr id="14" name="Right Arrow 13"/>
+          <p:cNvSpPr/>
+          <p:nvPr/>
+        </p:nvSpPr>
+        <p:spPr>
+          <a:xfrm>
+            <a:off x="5852160" y="3063240"/>
+            <a:ext cx="502920" cy="365760"/>
+          </a:xfrm>
+          <a:prstGeom prst="rightArrow">
+            <a:avLst/>
+          </a:prstGeom>
+          <a:solidFill>
+            <a:srgbClr val="CA5F00"/>
+          </a:solidFill>
+          <a:ln>
+            <a:noFill/>
+          </a:ln>
+          <a:effectLst/>
+        </p:spPr>
+        <p:style>
+          <a:lnRef idx="1">
+            <a:schemeClr val="accent1"/>
+          </a:lnRef>
+          <a:fillRef idx="3">
+            <a:schemeClr val="accent1"/>
+          </a:fillRef>
+          <a:effectRef idx="2">
+            <a:schemeClr val="accent1"/>
+          </a:effectRef>
+          <a:fontRef idx="minor">
+            <a:schemeClr val="lt1"/>
+          </a:fontRef>
+        </p:style>
+        <p:txBody>
+          <a:bodyPr rtlCol="0" anchor="ctr"/>
+          <a:lstStyle/>
+          <a:p>
+            <a:pPr algn="ctr"/>
+          </a:p>
+        </p:txBody>
+      </p:sp>
+      <p:sp>
+        <p:nvSpPr>
+          <p:cNvPr id="15" name="Rectangle 14"/>
+          <p:cNvSpPr/>
+          <p:nvPr/>
+        </p:nvSpPr>
+        <p:spPr>
+          <a:xfrm>
+            <a:off x="658368" y="4892040"/>
+            <a:ext cx="10881360" cy="960120"/>
+          </a:xfrm>
+          <a:prstGeom prst="rect">
+            <a:avLst/>
+          </a:prstGeom>
+          <a:solidFill>
+            <a:srgbClr val="EAF1FB"/>
+          </a:solidFill>
+          <a:ln>
+            <a:noFill/>
+          </a:ln>
+          <a:effectLst/>
+        </p:spPr>
+        <p:style>
+          <a:lnRef idx="1">
+            <a:schemeClr val="accent1"/>
+          </a:lnRef>
+          <a:fillRef idx="3">
+            <a:schemeClr val="accent1"/>
+          </a:fillRef>
+          <a:effectRef idx="2">
+            <a:schemeClr val="accent1"/>
+          </a:effectRef>
+          <a:fontRef idx="minor">
+            <a:schemeClr val="lt1"/>
+          </a:fontRef>
+        </p:style>
+        <p:txBody>
+          <a:bodyPr rtlCol="0" anchor="ctr"/>
+          <a:lstStyle/>
+          <a:p>
+            <a:pPr algn="ctr"/>
+          </a:p>
+        </p:txBody>
+      </p:sp>
+      <p:sp>
+        <p:nvSpPr>
+          <p:cNvPr id="16" name="TextBox 15"/>
+          <p:cNvSpPr txBox="1"/>
+          <p:nvPr/>
+        </p:nvSpPr>
+        <p:spPr>
+          <a:xfrm>
+            <a:off x="932688" y="5074920"/>
+            <a:ext cx="10332720" cy="685800"/>
+          </a:xfrm>
+          <a:prstGeom prst="rect">
+            <a:avLst/>
+          </a:prstGeom>
+          <a:noFill/>
+        </p:spPr>
+        <p:txBody>
+          <a:bodyPr wrap="square" lIns="0" rIns="0" tIns="0" bIns="0" anchor="ctr">
+            <a:spAutoFit/>
+          </a:bodyPr>
+          <a:lstStyle/>
+          <a:p>
+            <a:pPr algn="l">
+              <a:spcBef>
+                <a:spcPts val="0"/>
+              </a:spcBef>
+              <a:spcAft>
+                <a:spcPts val="0"/>
+              </a:spcAft>
+              <a:buNone/>
+            </a:pPr>
+            <a:r>
+              <a:rPr sz="1600" b="1">
+                <a:solidFill>
+                  <a:srgbClr val="103A5E"/>
+                </a:solidFill>
+                <a:latin typeface="Segoe UI Semibold"/>
+              </a:rPr>
+              <a:t>Local is the free on-ramp; Azure is the paid upsell. Apple stops at the device, with no cloud to graduate to. Windows plus Azure plus Microsoft's own apps is a funnel no competitor can match.</a:t>
+            </a:r>
+          </a:p>
+        </p:txBody>
+      </p:sp>
+      <p:sp>
+        <p:nvSpPr>
+          <p:cNvPr id="17" name="TextBox 16"/>
+          <p:cNvSpPr txBox="1"/>
+          <p:nvPr/>
+        </p:nvSpPr>
+        <p:spPr>
+          <a:xfrm>
+            <a:off x="502920" y="6419088"/>
+            <a:ext cx="8229600" cy="320040"/>
+          </a:xfrm>
+          <a:prstGeom prst="rect">
+            <a:avLst/>
+          </a:prstGeom>
+          <a:noFill/>
+        </p:spPr>
+        <p:txBody>
+          <a:bodyPr wrap="square" lIns="0" rIns="0" tIns="0" bIns="0">
+            <a:spAutoFit/>
+          </a:bodyPr>
+          <a:lstStyle/>
+          <a:p>
+            <a:pPr algn="l">
+              <a:spcBef>
+                <a:spcPts val="0"/>
+              </a:spcBef>
+              <a:spcAft>
+                <a:spcPts val="0"/>
+              </a:spcAft>
+              <a:buNone/>
+            </a:pPr>
+            <a:r>
+              <a:rPr sz="1000" b="0">
+                <a:solidFill>
+                  <a:srgbClr val="606060"/>
+                </a:solidFill>
+                <a:latin typeface="Segoe UI"/>
+              </a:rPr>
+              <a:t>WindowsNaturalVoices  ·  on-device speech, offline</a:t>
+            </a:r>
+          </a:p>
+        </p:txBody>
+      </p:sp>
+      <p:sp>
+        <p:nvSpPr>
+          <p:cNvPr id="18" name="TextBox 17"/>
+          <p:cNvSpPr txBox="1"/>
+          <p:nvPr/>
+        </p:nvSpPr>
+        <p:spPr>
+          <a:xfrm>
+            <a:off x="11155680" y="6419088"/>
+            <a:ext cx="640080" cy="320040"/>
+          </a:xfrm>
+          <a:prstGeom prst="rect">
+            <a:avLst/>
+          </a:prstGeom>
+          <a:noFill/>
+        </p:spPr>
+        <p:txBody>
+          <a:bodyPr wrap="square" lIns="0" rIns="0" tIns="0" bIns="0">
+            <a:spAutoFit/>
+          </a:bodyPr>
+          <a:lstStyle/>
+          <a:p>
+            <a:pPr algn="r">
+              <a:spcBef>
+                <a:spcPts val="0"/>
+              </a:spcBef>
+              <a:spcAft>
+                <a:spcPts val="0"/>
+              </a:spcAft>
+              <a:buNone/>
+            </a:pPr>
+            <a:r>
+              <a:rPr sz="1000" b="0">
+                <a:solidFill>
+                  <a:srgbClr val="606060"/>
+                </a:solidFill>
+                <a:latin typeface="Segoe UI"/>
+              </a:rPr>
+              <a:t>16</a:t>
+            </a:r>
+          </a:p>
+        </p:txBody>
+      </p:sp>
+    </p:spTree>
+  </p:cSld>
+  <p:clrMapOvr>
+    <a:masterClrMapping/>
+  </p:clrMapOvr>
+</p:sld>
+</file>
+
+<file path=ppt/slides/slide17.xml><?xml version="1.0" encoding="utf-8"?>
+<p:sld xmlns:a="http://schemas.openxmlformats.org/drawingml/2006/main" xmlns:p="http://schemas.openxmlformats.org/presentationml/2006/main" xmlns:r="http://schemas.openxmlformats.org/officeDocument/2006/relationships">
+  <p:cSld>
+    <p:spTree>
+      <p:nvGrpSpPr>
+        <p:cNvPr id="1" name=""/>
+        <p:cNvGrpSpPr/>
+        <p:nvPr/>
+      </p:nvGrpSpPr>
+      <p:grpSpPr/>
+      <p:sp>
+        <p:nvSpPr>
+          <p:cNvPr id="2" name="Rectangle 1"/>
+          <p:cNvSpPr/>
+          <p:nvPr/>
+        </p:nvSpPr>
+        <p:spPr>
+          <a:xfrm>
+            <a:off x="0" y="0"/>
+            <a:ext cx="12191695" cy="6858000"/>
+          </a:xfrm>
+          <a:prstGeom prst="rect">
+            <a:avLst/>
+          </a:prstGeom>
+          <a:solidFill>
+            <a:srgbClr val="103A5E"/>
+          </a:solidFill>
+          <a:ln>
+            <a:noFill/>
+          </a:ln>
+          <a:effectLst/>
+        </p:spPr>
+        <p:style>
+          <a:lnRef idx="1">
+            <a:schemeClr val="accent1"/>
+          </a:lnRef>
+          <a:fillRef idx="3">
+            <a:schemeClr val="accent1"/>
+          </a:fillRef>
+          <a:effectRef idx="2">
+            <a:schemeClr val="accent1"/>
+          </a:effectRef>
+          <a:fontRef idx="minor">
+            <a:schemeClr val="lt1"/>
+          </a:fontRef>
+        </p:style>
+        <p:txBody>
+          <a:bodyPr rtlCol="0" anchor="ctr"/>
+          <a:lstStyle/>
+          <a:p>
+            <a:pPr algn="ctr"/>
+          </a:p>
+        </p:txBody>
+      </p:sp>
+      <p:sp>
+        <p:nvSpPr>
+          <p:cNvPr id="3" name="Rectangle 2"/>
+          <p:cNvSpPr/>
+          <p:nvPr/>
+        </p:nvSpPr>
+        <p:spPr>
+          <a:xfrm>
+            <a:off x="0" y="0"/>
+            <a:ext cx="12191695" cy="146304"/>
+          </a:xfrm>
+          <a:prstGeom prst="rect">
+            <a:avLst/>
+          </a:prstGeom>
+          <a:solidFill>
+            <a:srgbClr val="0078D4"/>
+          </a:solidFill>
+          <a:ln>
+            <a:noFill/>
+          </a:ln>
+          <a:effectLst/>
+        </p:spPr>
+        <p:style>
+          <a:lnRef idx="1">
+            <a:schemeClr val="accent1"/>
+          </a:lnRef>
+          <a:fillRef idx="3">
+            <a:schemeClr val="accent1"/>
+          </a:fillRef>
+          <a:effectRef idx="2">
+            <a:schemeClr val="accent1"/>
+          </a:effectRef>
+          <a:fontRef idx="minor">
+            <a:schemeClr val="lt1"/>
+          </a:fontRef>
+        </p:style>
+        <p:txBody>
+          <a:bodyPr rtlCol="0" anchor="ctr"/>
+          <a:lstStyle/>
+          <a:p>
+            <a:pPr algn="ctr"/>
+          </a:p>
+        </p:txBody>
+      </p:sp>
+      <p:sp>
+        <p:nvSpPr>
+          <p:cNvPr id="4" name="TextBox 3"/>
+          <p:cNvSpPr txBox="1"/>
+          <p:nvPr/>
+        </p:nvSpPr>
+        <p:spPr>
+          <a:xfrm>
+            <a:off x="640080" y="594360"/>
+            <a:ext cx="10972800" cy="1097280"/>
+          </a:xfrm>
+          <a:prstGeom prst="rect">
+            <a:avLst/>
+          </a:prstGeom>
+          <a:noFill/>
+        </p:spPr>
+        <p:txBody>
+          <a:bodyPr wrap="square" lIns="0" rIns="0" tIns="0" bIns="0">
+            <a:spAutoFit/>
+          </a:bodyPr>
+          <a:lstStyle/>
+          <a:p>
+            <a:pPr algn="l">
+              <a:spcBef>
+                <a:spcPts val="0"/>
+              </a:spcBef>
+              <a:spcAft>
+                <a:spcPts val="600"/>
+              </a:spcAft>
+              <a:buNone/>
+            </a:pPr>
+            <a:r>
+              <a:rPr sz="1400" b="1">
+                <a:solidFill>
+                  <a:srgbClr val="8FC4F0"/>
+                </a:solidFill>
+                <a:latin typeface="Segoe UI Semibold"/>
+              </a:rPr>
+              <a:t>THE ASK TO MICROSOFT</a:t>
+            </a:r>
+          </a:p>
+          <a:p>
+            <a:pPr algn="l">
+              <a:spcBef>
+                <a:spcPts val="0"/>
+              </a:spcBef>
+              <a:spcAft>
+                <a:spcPts val="0"/>
+              </a:spcAft>
+              <a:buNone/>
+            </a:pPr>
+            <a:r>
+              <a:rPr sz="3000" b="1">
+                <a:solidFill>
+                  <a:srgbClr val="FFFFFF"/>
+                </a:solidFill>
+                <a:latin typeface="Segoe UI Semibold"/>
+              </a:rPr>
+              <a:t>Ship this as a first-class Windows speech API</a:t>
+            </a:r>
+          </a:p>
+        </p:txBody>
+      </p:sp>
+      <p:sp>
+        <p:nvSpPr>
+          <p:cNvPr id="5" name="TextBox 4"/>
+          <p:cNvSpPr txBox="1"/>
+          <p:nvPr/>
+        </p:nvSpPr>
+        <p:spPr>
+          <a:xfrm>
+            <a:off x="640080" y="1828800"/>
+            <a:ext cx="10881360" cy="1005840"/>
+          </a:xfrm>
+          <a:prstGeom prst="rect">
+            <a:avLst/>
+          </a:prstGeom>
+          <a:noFill/>
+        </p:spPr>
+        <p:txBody>
+          <a:bodyPr wrap="square" lIns="0" rIns="0" tIns="0" bIns="0">
+            <a:spAutoFit/>
+          </a:bodyPr>
+          <a:lstStyle/>
+          <a:p>
+            <a:pPr algn="l">
+              <a:spcBef>
+                <a:spcPts val="0"/>
+              </a:spcBef>
+              <a:spcAft>
+                <a:spcPts val="0"/>
+              </a:spcAft>
+              <a:buNone/>
+            </a:pPr>
+            <a:r>
+              <a:rPr sz="1600" b="0">
+                <a:solidFill>
+                  <a:srgbClr val="CFE0F3"/>
+                </a:solidFill>
+                <a:latin typeface="Segoe UI"/>
+              </a:rPr>
+              <a:t>This repo is a working reference implementation of what it should look like. Take the hack out; make it supported:</a:t>
+            </a:r>
+          </a:p>
+        </p:txBody>
+      </p:sp>
+      <p:sp>
+        <p:nvSpPr>
+          <p:cNvPr id="6" name="TextBox 5"/>
+          <p:cNvSpPr txBox="1"/>
+          <p:nvPr/>
+        </p:nvSpPr>
+        <p:spPr>
+          <a:xfrm>
+            <a:off x="914400" y="2834640"/>
+            <a:ext cx="10424160" cy="2194560"/>
+          </a:xfrm>
+          <a:prstGeom prst="rect">
+            <a:avLst/>
+          </a:prstGeom>
+          <a:noFill/>
+        </p:spPr>
+        <p:txBody>
+          <a:bodyPr wrap="square" lIns="0" rIns="0" tIns="0" bIns="0">
+            <a:spAutoFit/>
+          </a:bodyPr>
+          <a:lstStyle/>
+          <a:p>
+            <a:pPr algn="l">
+              <a:spcBef>
+                <a:spcPts val="0"/>
+              </a:spcBef>
+              <a:spcAft>
+                <a:spcPts val="800"/>
+              </a:spcAft>
+              <a:buFont typeface="Segoe UI"/>
+              <a:buChar char="•"/>
+            </a:pPr>
+            <a:r>
+              <a:rPr sz="1600" b="0">
+                <a:solidFill>
+                  <a:srgbClr val="FFFFFF"/>
+                </a:solidFill>
+                <a:latin typeface="Segoe UI"/>
+              </a:rPr>
+              <a:t>Enumerate installed Natural voices and synthesize offline through the on-device HD runtime.</a:t>
+            </a:r>
+          </a:p>
+          <a:p>
+            <a:pPr algn="l">
+              <a:spcBef>
+                <a:spcPts val="0"/>
+              </a:spcBef>
+              <a:spcAft>
+                <a:spcPts val="800"/>
+              </a:spcAft>
+              <a:buFont typeface="Segoe UI"/>
+              <a:buChar char="•"/>
+            </a:pPr>
+            <a:r>
+              <a:rPr sz="1600" b="0">
+                <a:solidFill>
+                  <a:srgbClr val="FFFFFF"/>
+                </a:solidFill>
+                <a:latin typeface="Segoe UI"/>
+              </a:rPr>
+              <a:t>Stream synthesis and recognition live, with word-boundary events and immutable finals.</a:t>
+            </a:r>
+          </a:p>
+          <a:p>
+            <a:pPr algn="l">
+              <a:spcBef>
+                <a:spcPts val="0"/>
+              </a:spcBef>
+              <a:spcAft>
+                <a:spcPts val="800"/>
+              </a:spcAft>
+              <a:buFont typeface="Segoe UI"/>
+              <a:buChar char="•"/>
+            </a:pPr>
+            <a:r>
+              <a:rPr sz="1600" b="0">
+                <a:solidFill>
+                  <a:srgbClr val="FFFFFF"/>
+                </a:solidFill>
+                <a:latin typeface="Segoe UI"/>
+              </a:rPr>
+              <a:t>Recognize speech on-device with the same Live Captions model, one recognizer per audio source.</a:t>
+            </a:r>
+          </a:p>
+          <a:p>
+            <a:pPr algn="l">
+              <a:spcBef>
+                <a:spcPts val="0"/>
+              </a:spcBef>
+              <a:spcAft>
+                <a:spcPts val="800"/>
+              </a:spcAft>
+              <a:buFont typeface="Segoe UI"/>
+              <a:buChar char="•"/>
+            </a:pPr>
+            <a:r>
+              <a:rPr sz="1600" b="0">
+                <a:solidFill>
+                  <a:srgbClr val="FFFFFF"/>
+                </a:solidFill>
+                <a:latin typeface="Segoe UI"/>
+              </a:rPr>
+              <a:t>Drive a full on-device conversation loop: capture, endpoint, recognize, respond, speak, with barge-in and a place to plug in intelligence.</a:t>
+            </a:r>
+          </a:p>
+          <a:p>
+            <a:pPr algn="l">
+              <a:spcBef>
+                <a:spcPts val="0"/>
+              </a:spcBef>
+              <a:spcAft>
+                <a:spcPts val="800"/>
+              </a:spcAft>
+              <a:buFont typeface="Segoe UI"/>
+              <a:buChar char="•"/>
+            </a:pPr>
+            <a:r>
+              <a:rPr sz="1600" b="0">
                 <a:solidFill>
                   <a:srgbClr val="FFFFFF"/>
                 </a:solidFill>
@@ -7365,7 +9885,7 @@
                 </a:solidFill>
                 <a:latin typeface="Segoe UI Semibold"/>
               </a:rPr>
-              <a:t>Then every app (Edge, Teams, Office, media players, accessibility tools) gets instant, private, multilingual, on-device narration for free, with a paved road to Azure.</a:t>
+              <a:t>Then every app (Edge, Teams, Office, media players, accessibility tools) gets instant, private, multilingual, on-device narration and transcription for free, with a paved road to Azure.</a:t>
             </a:r>
           </a:p>
         </p:txBody>
@@ -7990,7 +10510,7 @@
                 </a:solidFill>
                 <a:latin typeface="Segoe UI"/>
               </a:rPr>
-              <a:t>On-device speech and neural TTS already ship to third-party apps.</a:t>
+              <a:t>On-device speech recognition (SpeechAnalyzer) and neural TTS ship to apps.</a:t>
             </a:r>
           </a:p>
           <a:p>
@@ -8011,7 +10531,7 @@
                 </a:solidFill>
                 <a:latin typeface="Segoe UI"/>
               </a:rPr>
-              <a:t>It proves local-first AI is real, shipped, and wanted by developers.</a:t>
+              <a:t>It proves local-first speech, in and out, is real, shipped, and wanted.</a:t>
             </a:r>
           </a:p>
           <a:p>
@@ -8209,7 +10729,7 @@
                 </a:solidFill>
                 <a:latin typeface="Segoe UI"/>
               </a:rPr>
-              <a:t>The same on-device HD voices are already on the machine, free and offline.</a:t>
+              <a:t>The same on-device HD voices AND Live Captions recognition already ship, free.</a:t>
             </a:r>
           </a:p>
           <a:p>
@@ -8337,7 +10857,7 @@
                 </a:solidFill>
                 <a:latin typeface="Segoe UI"/>
               </a:rPr>
-              <a:t>WindowsNaturalVoices  ·  on-device HD voices, offline</a:t>
+              <a:t>WindowsNaturalVoices  ·  on-device speech, offline</a:t>
             </a:r>
           </a:p>
         </p:txBody>
@@ -9047,7 +11567,7 @@
                 </a:solidFill>
                 <a:latin typeface="Segoe UI"/>
               </a:rPr>
-              <a:t>WindowsNaturalVoices  ·  on-device HD voices, offline</a:t>
+              <a:t>WindowsNaturalVoices  ·  on-device speech, offline</a:t>
             </a:r>
           </a:p>
         </p:txBody>
@@ -9582,7 +12102,7 @@
                 </a:solidFill>
                 <a:latin typeface="Segoe UI"/>
               </a:rPr>
-              <a:t>WindowsNaturalVoices  ·  on-device HD voices, offline</a:t>
+              <a:t>WindowsNaturalVoices  ·  on-device speech, offline</a:t>
             </a:r>
           </a:p>
         </p:txBody>
@@ -10308,7 +12828,7 @@
                 </a:solidFill>
                 <a:latin typeface="Segoe UI"/>
               </a:rPr>
-              <a:t>WindowsNaturalVoices  ·  on-device HD voices, offline</a:t>
+              <a:t>WindowsNaturalVoices  ·  on-device speech, offline</a:t>
             </a:r>
           </a:p>
         </p:txBody>
@@ -10800,7 +13320,7 @@
                 </a:solidFill>
                 <a:latin typeface="Segoe UI"/>
               </a:rPr>
-              <a:t>WindowsNaturalVoices  ·  on-device HD voices, offline</a:t>
+              <a:t>WindowsNaturalVoices  ·  on-device speech, offline</a:t>
             </a:r>
           </a:p>
         </p:txBody>
@@ -11690,7 +14210,7 @@
                 </a:solidFill>
                 <a:latin typeface="Segoe UI"/>
               </a:rPr>
-              <a:t>WindowsNaturalVoices  ·  on-device HD voices, offline</a:t>
+              <a:t>WindowsNaturalVoices  ·  on-device speech, offline</a:t>
             </a:r>
           </a:p>
         </p:txBody>

</xml_diff>